<commit_message>
updates on APP RS422 test and CAN test
</commit_message>
<xml_diff>
--- a/stn/stn_test_fw_solution.pptx
+++ b/stn/stn_test_fw_solution.pptx
@@ -265,7 +265,7 @@
           <a:p>
             <a:fld id="{AA100CEF-43AD-4927-89A2-F66B823BF21E}" type="datetimeFigureOut">
               <a:rPr lang="zh-CN" altLang="en-US" smtClean="0"/>
-              <a:t>2025/8/19</a:t>
+              <a:t>2025/9/6</a:t>
             </a:fld>
             <a:endParaRPr lang="zh-CN" altLang="en-US"/>
           </a:p>
@@ -463,7 +463,7 @@
           <a:p>
             <a:fld id="{AA100CEF-43AD-4927-89A2-F66B823BF21E}" type="datetimeFigureOut">
               <a:rPr lang="zh-CN" altLang="en-US" smtClean="0"/>
-              <a:t>2025/8/19</a:t>
+              <a:t>2025/9/6</a:t>
             </a:fld>
             <a:endParaRPr lang="zh-CN" altLang="en-US"/>
           </a:p>
@@ -671,7 +671,7 @@
           <a:p>
             <a:fld id="{AA100CEF-43AD-4927-89A2-F66B823BF21E}" type="datetimeFigureOut">
               <a:rPr lang="zh-CN" altLang="en-US" smtClean="0"/>
-              <a:t>2025/8/19</a:t>
+              <a:t>2025/9/6</a:t>
             </a:fld>
             <a:endParaRPr lang="zh-CN" altLang="en-US"/>
           </a:p>
@@ -869,7 +869,7 @@
           <a:p>
             <a:fld id="{AA100CEF-43AD-4927-89A2-F66B823BF21E}" type="datetimeFigureOut">
               <a:rPr lang="zh-CN" altLang="en-US" smtClean="0"/>
-              <a:t>2025/8/19</a:t>
+              <a:t>2025/9/6</a:t>
             </a:fld>
             <a:endParaRPr lang="zh-CN" altLang="en-US"/>
           </a:p>
@@ -1144,7 +1144,7 @@
           <a:p>
             <a:fld id="{AA100CEF-43AD-4927-89A2-F66B823BF21E}" type="datetimeFigureOut">
               <a:rPr lang="zh-CN" altLang="en-US" smtClean="0"/>
-              <a:t>2025/8/19</a:t>
+              <a:t>2025/9/6</a:t>
             </a:fld>
             <a:endParaRPr lang="zh-CN" altLang="en-US"/>
           </a:p>
@@ -1409,7 +1409,7 @@
           <a:p>
             <a:fld id="{AA100CEF-43AD-4927-89A2-F66B823BF21E}" type="datetimeFigureOut">
               <a:rPr lang="zh-CN" altLang="en-US" smtClean="0"/>
-              <a:t>2025/8/19</a:t>
+              <a:t>2025/9/6</a:t>
             </a:fld>
             <a:endParaRPr lang="zh-CN" altLang="en-US"/>
           </a:p>
@@ -1821,7 +1821,7 @@
           <a:p>
             <a:fld id="{AA100CEF-43AD-4927-89A2-F66B823BF21E}" type="datetimeFigureOut">
               <a:rPr lang="zh-CN" altLang="en-US" smtClean="0"/>
-              <a:t>2025/8/19</a:t>
+              <a:t>2025/9/6</a:t>
             </a:fld>
             <a:endParaRPr lang="zh-CN" altLang="en-US"/>
           </a:p>
@@ -1962,7 +1962,7 @@
           <a:p>
             <a:fld id="{AA100CEF-43AD-4927-89A2-F66B823BF21E}" type="datetimeFigureOut">
               <a:rPr lang="zh-CN" altLang="en-US" smtClean="0"/>
-              <a:t>2025/8/19</a:t>
+              <a:t>2025/9/6</a:t>
             </a:fld>
             <a:endParaRPr lang="zh-CN" altLang="en-US"/>
           </a:p>
@@ -2075,7 +2075,7 @@
           <a:p>
             <a:fld id="{AA100CEF-43AD-4927-89A2-F66B823BF21E}" type="datetimeFigureOut">
               <a:rPr lang="zh-CN" altLang="en-US" smtClean="0"/>
-              <a:t>2025/8/19</a:t>
+              <a:t>2025/9/6</a:t>
             </a:fld>
             <a:endParaRPr lang="zh-CN" altLang="en-US"/>
           </a:p>
@@ -2386,7 +2386,7 @@
           <a:p>
             <a:fld id="{AA100CEF-43AD-4927-89A2-F66B823BF21E}" type="datetimeFigureOut">
               <a:rPr lang="zh-CN" altLang="en-US" smtClean="0"/>
-              <a:t>2025/8/19</a:t>
+              <a:t>2025/9/6</a:t>
             </a:fld>
             <a:endParaRPr lang="zh-CN" altLang="en-US"/>
           </a:p>
@@ -2674,7 +2674,7 @@
           <a:p>
             <a:fld id="{AA100CEF-43AD-4927-89A2-F66B823BF21E}" type="datetimeFigureOut">
               <a:rPr lang="zh-CN" altLang="en-US" smtClean="0"/>
-              <a:t>2025/8/19</a:t>
+              <a:t>2025/9/6</a:t>
             </a:fld>
             <a:endParaRPr lang="zh-CN" altLang="en-US"/>
           </a:p>
@@ -2915,7 +2915,7 @@
           <a:p>
             <a:fld id="{AA100CEF-43AD-4927-89A2-F66B823BF21E}" type="datetimeFigureOut">
               <a:rPr lang="zh-CN" altLang="en-US" smtClean="0"/>
-              <a:t>2025/8/19</a:t>
+              <a:t>2025/9/6</a:t>
             </a:fld>
             <a:endParaRPr lang="zh-CN" altLang="en-US"/>
           </a:p>
@@ -11052,10 +11052,10 @@
       </p:grpSpPr>
       <p:grpSp>
         <p:nvGrpSpPr>
-          <p:cNvPr id="21" name="组合 20">
-            <a:extLst>
-              <a:ext uri="{FF2B5EF4-FFF2-40B4-BE49-F238E27FC236}">
-                <a16:creationId xmlns:a16="http://schemas.microsoft.com/office/drawing/2014/main" id="{1E9912D7-C6A2-AAA6-FAF4-701ECA528C29}"/>
+          <p:cNvPr id="23" name="组合 22">
+            <a:extLst>
+              <a:ext uri="{FF2B5EF4-FFF2-40B4-BE49-F238E27FC236}">
+                <a16:creationId xmlns:a16="http://schemas.microsoft.com/office/drawing/2014/main" id="{404DE787-C362-C59F-538A-455AF12F75B9}"/>
               </a:ext>
             </a:extLst>
           </p:cNvPr>
@@ -11064,9 +11064,9 @@
         </p:nvGrpSpPr>
         <p:grpSpPr>
           <a:xfrm>
-            <a:off x="2884096" y="1052423"/>
+            <a:off x="382943" y="353176"/>
             <a:ext cx="3551208" cy="3118945"/>
-            <a:chOff x="2884096" y="1052423"/>
+            <a:chOff x="382943" y="353176"/>
             <a:chExt cx="3551208" cy="3118945"/>
           </a:xfrm>
         </p:grpSpPr>
@@ -11084,7 +11084,7 @@
           </p:nvSpPr>
           <p:spPr>
             <a:xfrm>
-              <a:off x="2884096" y="1052423"/>
+              <a:off x="382943" y="353176"/>
               <a:ext cx="1207698" cy="369332"/>
             </a:xfrm>
             <a:prstGeom prst="rect">
@@ -11119,7 +11119,7 @@
           </p:nvSpPr>
           <p:spPr>
             <a:xfrm>
-              <a:off x="2930104" y="1654834"/>
+              <a:off x="428951" y="955587"/>
               <a:ext cx="1115683" cy="454324"/>
             </a:xfrm>
             <a:prstGeom prst="flowChartProcess">
@@ -11169,7 +11169,7 @@
           </p:nvSpPr>
           <p:spPr>
             <a:xfrm>
-              <a:off x="2930104" y="2342237"/>
+              <a:off x="428951" y="1642990"/>
               <a:ext cx="1115683" cy="454324"/>
             </a:xfrm>
             <a:prstGeom prst="flowChartProcess">
@@ -11219,7 +11219,7 @@
           </p:nvSpPr>
           <p:spPr>
             <a:xfrm>
-              <a:off x="2930104" y="3029640"/>
+              <a:off x="428951" y="2330393"/>
               <a:ext cx="1115683" cy="454324"/>
             </a:xfrm>
             <a:prstGeom prst="flowChartProcess">
@@ -11269,7 +11269,7 @@
           </p:nvSpPr>
           <p:spPr>
             <a:xfrm>
-              <a:off x="2930104" y="3717044"/>
+              <a:off x="428951" y="3017797"/>
               <a:ext cx="1115683" cy="454324"/>
             </a:xfrm>
             <a:prstGeom prst="flowChartProcess">
@@ -11319,7 +11319,7 @@
           </p:nvSpPr>
           <p:spPr>
             <a:xfrm>
-              <a:off x="5227606" y="1052423"/>
+              <a:off x="2726453" y="353176"/>
               <a:ext cx="1207698" cy="369332"/>
             </a:xfrm>
             <a:prstGeom prst="rect">
@@ -11354,7 +11354,7 @@
           </p:nvSpPr>
           <p:spPr>
             <a:xfrm>
-              <a:off x="5273614" y="1654834"/>
+              <a:off x="2772461" y="955587"/>
               <a:ext cx="1115683" cy="454324"/>
             </a:xfrm>
             <a:prstGeom prst="flowChartProcess">
@@ -11404,7 +11404,7 @@
           </p:nvSpPr>
           <p:spPr>
             <a:xfrm>
-              <a:off x="5273614" y="2342237"/>
+              <a:off x="2772461" y="1642990"/>
               <a:ext cx="1115683" cy="454324"/>
             </a:xfrm>
             <a:prstGeom prst="flowChartProcess">
@@ -11454,7 +11454,7 @@
           </p:nvSpPr>
           <p:spPr>
             <a:xfrm>
-              <a:off x="5273614" y="3029640"/>
+              <a:off x="2772461" y="2330393"/>
               <a:ext cx="1115683" cy="454324"/>
             </a:xfrm>
             <a:prstGeom prst="flowChartProcess">
@@ -11504,7 +11504,7 @@
           </p:nvSpPr>
           <p:spPr>
             <a:xfrm>
-              <a:off x="5273614" y="3717044"/>
+              <a:off x="2772461" y="3017797"/>
               <a:ext cx="1115683" cy="454324"/>
             </a:xfrm>
             <a:prstGeom prst="flowChartProcess">
@@ -11557,7 +11557,7 @@
           </p:nvCxnSpPr>
           <p:spPr>
             <a:xfrm>
-              <a:off x="4045787" y="1881996"/>
+              <a:off x="1544634" y="1182749"/>
               <a:ext cx="1227827" cy="687403"/>
             </a:xfrm>
             <a:prstGeom prst="straightConnector1">
@@ -11599,7 +11599,7 @@
           </p:nvCxnSpPr>
           <p:spPr>
             <a:xfrm>
-              <a:off x="4045787" y="2569399"/>
+              <a:off x="1544634" y="1870152"/>
               <a:ext cx="1227827" cy="687403"/>
             </a:xfrm>
             <a:prstGeom prst="straightConnector1">
@@ -11641,7 +11641,7 @@
           </p:nvCxnSpPr>
           <p:spPr>
             <a:xfrm>
-              <a:off x="4045787" y="3256802"/>
+              <a:off x="1544634" y="2557555"/>
               <a:ext cx="1227827" cy="687404"/>
             </a:xfrm>
             <a:prstGeom prst="straightConnector1">
@@ -11683,7 +11683,7 @@
           </p:nvCxnSpPr>
           <p:spPr>
             <a:xfrm flipV="1">
-              <a:off x="4045787" y="1881996"/>
+              <a:off x="1544634" y="1182749"/>
               <a:ext cx="1227827" cy="2062210"/>
             </a:xfrm>
             <a:prstGeom prst="straightConnector1">
@@ -11709,6 +11709,712 @@
           </p:style>
         </p:cxnSp>
       </p:grpSp>
+      <p:sp>
+        <p:nvSpPr>
+          <p:cNvPr id="3" name="文本框 2">
+            <a:extLst>
+              <a:ext uri="{FF2B5EF4-FFF2-40B4-BE49-F238E27FC236}">
+                <a16:creationId xmlns:a16="http://schemas.microsoft.com/office/drawing/2014/main" id="{FF9340DA-28C2-D53D-A421-AB943919EBC5}"/>
+              </a:ext>
+            </a:extLst>
+          </p:cNvPr>
+          <p:cNvSpPr txBox="1"/>
+          <p:nvPr/>
+        </p:nvSpPr>
+        <p:spPr>
+          <a:xfrm>
+            <a:off x="6258412" y="353176"/>
+            <a:ext cx="1207698" cy="369332"/>
+          </a:xfrm>
+          <a:prstGeom prst="rect">
+            <a:avLst/>
+          </a:prstGeom>
+          <a:noFill/>
+        </p:spPr>
+        <p:txBody>
+          <a:bodyPr wrap="square" rtlCol="0">
+            <a:spAutoFit/>
+          </a:bodyPr>
+          <a:lstStyle/>
+          <a:p>
+            <a:r>
+              <a:rPr lang="en-US" altLang="zh-CN" b="1" dirty="0"/>
+              <a:t>CAN TX</a:t>
+            </a:r>
+          </a:p>
+        </p:txBody>
+      </p:sp>
+      <p:sp>
+        <p:nvSpPr>
+          <p:cNvPr id="13" name="流程图: 过程 12">
+            <a:extLst>
+              <a:ext uri="{FF2B5EF4-FFF2-40B4-BE49-F238E27FC236}">
+                <a16:creationId xmlns:a16="http://schemas.microsoft.com/office/drawing/2014/main" id="{5C8A793E-FB00-6DBF-ECB9-ACE3D0E9B9DE}"/>
+              </a:ext>
+            </a:extLst>
+          </p:cNvPr>
+          <p:cNvSpPr/>
+          <p:nvPr/>
+        </p:nvSpPr>
+        <p:spPr>
+          <a:xfrm>
+            <a:off x="6017263" y="787786"/>
+            <a:ext cx="1505632" cy="369332"/>
+          </a:xfrm>
+          <a:prstGeom prst="flowChartProcess">
+            <a:avLst/>
+          </a:prstGeom>
+        </p:spPr>
+        <p:style>
+          <a:lnRef idx="2">
+            <a:schemeClr val="accent1">
+              <a:shade val="15000"/>
+            </a:schemeClr>
+          </a:lnRef>
+          <a:fillRef idx="1">
+            <a:schemeClr val="accent1"/>
+          </a:fillRef>
+          <a:effectRef idx="0">
+            <a:schemeClr val="accent1"/>
+          </a:effectRef>
+          <a:fontRef idx="minor">
+            <a:schemeClr val="lt1"/>
+          </a:fontRef>
+        </p:style>
+        <p:txBody>
+          <a:bodyPr rtlCol="0" anchor="ctr"/>
+          <a:lstStyle/>
+          <a:p>
+            <a:pPr algn="ctr"/>
+            <a:r>
+              <a:rPr lang="en-US" altLang="zh-CN" dirty="0"/>
+              <a:t>TX1-MSG0</a:t>
+            </a:r>
+            <a:endParaRPr lang="zh-CN" altLang="en-US" dirty="0"/>
+          </a:p>
+        </p:txBody>
+      </p:sp>
+      <p:sp>
+        <p:nvSpPr>
+          <p:cNvPr id="15" name="流程图: 过程 14">
+            <a:extLst>
+              <a:ext uri="{FF2B5EF4-FFF2-40B4-BE49-F238E27FC236}">
+                <a16:creationId xmlns:a16="http://schemas.microsoft.com/office/drawing/2014/main" id="{B1F57041-7331-5476-C040-61C610E4152A}"/>
+              </a:ext>
+            </a:extLst>
+          </p:cNvPr>
+          <p:cNvSpPr/>
+          <p:nvPr/>
+        </p:nvSpPr>
+        <p:spPr>
+          <a:xfrm>
+            <a:off x="6017263" y="1759943"/>
+            <a:ext cx="1505632" cy="369332"/>
+          </a:xfrm>
+          <a:prstGeom prst="flowChartProcess">
+            <a:avLst/>
+          </a:prstGeom>
+        </p:spPr>
+        <p:style>
+          <a:lnRef idx="2">
+            <a:schemeClr val="accent1">
+              <a:shade val="15000"/>
+            </a:schemeClr>
+          </a:lnRef>
+          <a:fillRef idx="1">
+            <a:schemeClr val="accent1"/>
+          </a:fillRef>
+          <a:effectRef idx="0">
+            <a:schemeClr val="accent1"/>
+          </a:effectRef>
+          <a:fontRef idx="minor">
+            <a:schemeClr val="lt1"/>
+          </a:fontRef>
+        </p:style>
+        <p:txBody>
+          <a:bodyPr rtlCol="0" anchor="ctr"/>
+          <a:lstStyle/>
+          <a:p>
+            <a:pPr algn="ctr"/>
+            <a:r>
+              <a:rPr lang="en-US" altLang="zh-CN" dirty="0"/>
+              <a:t>TX2-MSG0</a:t>
+            </a:r>
+            <a:endParaRPr lang="zh-CN" altLang="en-US" dirty="0"/>
+          </a:p>
+        </p:txBody>
+      </p:sp>
+      <p:sp>
+        <p:nvSpPr>
+          <p:cNvPr id="17" name="流程图: 过程 16">
+            <a:extLst>
+              <a:ext uri="{FF2B5EF4-FFF2-40B4-BE49-F238E27FC236}">
+                <a16:creationId xmlns:a16="http://schemas.microsoft.com/office/drawing/2014/main" id="{F116CB81-E850-96ED-C0FF-46D40081688B}"/>
+              </a:ext>
+            </a:extLst>
+          </p:cNvPr>
+          <p:cNvSpPr/>
+          <p:nvPr/>
+        </p:nvSpPr>
+        <p:spPr>
+          <a:xfrm>
+            <a:off x="6017263" y="2732100"/>
+            <a:ext cx="1505632" cy="326746"/>
+          </a:xfrm>
+          <a:prstGeom prst="flowChartProcess">
+            <a:avLst/>
+          </a:prstGeom>
+        </p:spPr>
+        <p:style>
+          <a:lnRef idx="2">
+            <a:schemeClr val="accent1">
+              <a:shade val="15000"/>
+            </a:schemeClr>
+          </a:lnRef>
+          <a:fillRef idx="1">
+            <a:schemeClr val="accent1"/>
+          </a:fillRef>
+          <a:effectRef idx="0">
+            <a:schemeClr val="accent1"/>
+          </a:effectRef>
+          <a:fontRef idx="minor">
+            <a:schemeClr val="lt1"/>
+          </a:fontRef>
+        </p:style>
+        <p:txBody>
+          <a:bodyPr rtlCol="0" anchor="ctr"/>
+          <a:lstStyle/>
+          <a:p>
+            <a:pPr algn="ctr"/>
+            <a:r>
+              <a:rPr lang="en-US" altLang="zh-CN" dirty="0"/>
+              <a:t>TX3-MSG0</a:t>
+            </a:r>
+            <a:endParaRPr lang="zh-CN" altLang="en-US" dirty="0"/>
+          </a:p>
+        </p:txBody>
+      </p:sp>
+      <p:sp>
+        <p:nvSpPr>
+          <p:cNvPr id="19" name="流程图: 过程 18">
+            <a:extLst>
+              <a:ext uri="{FF2B5EF4-FFF2-40B4-BE49-F238E27FC236}">
+                <a16:creationId xmlns:a16="http://schemas.microsoft.com/office/drawing/2014/main" id="{83860E17-F0D5-3A7B-1150-B5FA0D474E7D}"/>
+              </a:ext>
+            </a:extLst>
+          </p:cNvPr>
+          <p:cNvSpPr/>
+          <p:nvPr/>
+        </p:nvSpPr>
+        <p:spPr>
+          <a:xfrm>
+            <a:off x="6017263" y="3661670"/>
+            <a:ext cx="1505632" cy="326746"/>
+          </a:xfrm>
+          <a:prstGeom prst="flowChartProcess">
+            <a:avLst/>
+          </a:prstGeom>
+        </p:spPr>
+        <p:style>
+          <a:lnRef idx="2">
+            <a:schemeClr val="accent1">
+              <a:shade val="15000"/>
+            </a:schemeClr>
+          </a:lnRef>
+          <a:fillRef idx="1">
+            <a:schemeClr val="accent1"/>
+          </a:fillRef>
+          <a:effectRef idx="0">
+            <a:schemeClr val="accent1"/>
+          </a:effectRef>
+          <a:fontRef idx="minor">
+            <a:schemeClr val="lt1"/>
+          </a:fontRef>
+        </p:style>
+        <p:txBody>
+          <a:bodyPr rtlCol="0" anchor="ctr"/>
+          <a:lstStyle/>
+          <a:p>
+            <a:pPr algn="ctr"/>
+            <a:r>
+              <a:rPr lang="en-US" altLang="zh-CN" dirty="0"/>
+              <a:t>TX4-MSG0</a:t>
+            </a:r>
+            <a:endParaRPr lang="zh-CN" altLang="en-US" dirty="0"/>
+          </a:p>
+        </p:txBody>
+      </p:sp>
+      <p:sp>
+        <p:nvSpPr>
+          <p:cNvPr id="22" name="文本框 21">
+            <a:extLst>
+              <a:ext uri="{FF2B5EF4-FFF2-40B4-BE49-F238E27FC236}">
+                <a16:creationId xmlns:a16="http://schemas.microsoft.com/office/drawing/2014/main" id="{556E670A-2A49-911F-9E6F-A89B4509CB0A}"/>
+              </a:ext>
+            </a:extLst>
+          </p:cNvPr>
+          <p:cNvSpPr txBox="1"/>
+          <p:nvPr/>
+        </p:nvSpPr>
+        <p:spPr>
+          <a:xfrm>
+            <a:off x="9381850" y="353176"/>
+            <a:ext cx="1207698" cy="369332"/>
+          </a:xfrm>
+          <a:prstGeom prst="rect">
+            <a:avLst/>
+          </a:prstGeom>
+          <a:noFill/>
+        </p:spPr>
+        <p:txBody>
+          <a:bodyPr wrap="square" rtlCol="0">
+            <a:spAutoFit/>
+          </a:bodyPr>
+          <a:lstStyle/>
+          <a:p>
+            <a:r>
+              <a:rPr lang="en-US" altLang="zh-CN" b="1" dirty="0"/>
+              <a:t>CAN RX</a:t>
+            </a:r>
+          </a:p>
+        </p:txBody>
+      </p:sp>
+      <p:sp>
+        <p:nvSpPr>
+          <p:cNvPr id="25" name="流程图: 过程 24">
+            <a:extLst>
+              <a:ext uri="{FF2B5EF4-FFF2-40B4-BE49-F238E27FC236}">
+                <a16:creationId xmlns:a16="http://schemas.microsoft.com/office/drawing/2014/main" id="{06F6D7FC-34A1-A141-8AEF-F4FF0F98CF06}"/>
+              </a:ext>
+            </a:extLst>
+          </p:cNvPr>
+          <p:cNvSpPr/>
+          <p:nvPr/>
+        </p:nvSpPr>
+        <p:spPr>
+          <a:xfrm>
+            <a:off x="9232883" y="770921"/>
+            <a:ext cx="1505632" cy="369332"/>
+          </a:xfrm>
+          <a:prstGeom prst="flowChartProcess">
+            <a:avLst/>
+          </a:prstGeom>
+        </p:spPr>
+        <p:style>
+          <a:lnRef idx="2">
+            <a:schemeClr val="accent1">
+              <a:shade val="15000"/>
+            </a:schemeClr>
+          </a:lnRef>
+          <a:fillRef idx="1">
+            <a:schemeClr val="accent1"/>
+          </a:fillRef>
+          <a:effectRef idx="0">
+            <a:schemeClr val="accent1"/>
+          </a:effectRef>
+          <a:fontRef idx="minor">
+            <a:schemeClr val="lt1"/>
+          </a:fontRef>
+        </p:style>
+        <p:txBody>
+          <a:bodyPr rtlCol="0" anchor="ctr"/>
+          <a:lstStyle/>
+          <a:p>
+            <a:pPr algn="ctr"/>
+            <a:r>
+              <a:rPr lang="en-US" altLang="zh-CN" dirty="0"/>
+              <a:t>RX1-MSG0</a:t>
+            </a:r>
+            <a:endParaRPr lang="zh-CN" altLang="en-US" dirty="0"/>
+          </a:p>
+        </p:txBody>
+      </p:sp>
+      <p:sp>
+        <p:nvSpPr>
+          <p:cNvPr id="26" name="流程图: 过程 25">
+            <a:extLst>
+              <a:ext uri="{FF2B5EF4-FFF2-40B4-BE49-F238E27FC236}">
+                <a16:creationId xmlns:a16="http://schemas.microsoft.com/office/drawing/2014/main" id="{D7CD7E09-CFC8-E4C5-0DFB-1751F26EB582}"/>
+              </a:ext>
+            </a:extLst>
+          </p:cNvPr>
+          <p:cNvSpPr/>
+          <p:nvPr/>
+        </p:nvSpPr>
+        <p:spPr>
+          <a:xfrm>
+            <a:off x="9232883" y="1157118"/>
+            <a:ext cx="1505632" cy="369332"/>
+          </a:xfrm>
+          <a:prstGeom prst="flowChartProcess">
+            <a:avLst/>
+          </a:prstGeom>
+        </p:spPr>
+        <p:style>
+          <a:lnRef idx="2">
+            <a:schemeClr val="accent1">
+              <a:shade val="15000"/>
+            </a:schemeClr>
+          </a:lnRef>
+          <a:fillRef idx="1">
+            <a:schemeClr val="accent1"/>
+          </a:fillRef>
+          <a:effectRef idx="0">
+            <a:schemeClr val="accent1"/>
+          </a:effectRef>
+          <a:fontRef idx="minor">
+            <a:schemeClr val="lt1"/>
+          </a:fontRef>
+        </p:style>
+        <p:txBody>
+          <a:bodyPr rtlCol="0" anchor="ctr"/>
+          <a:lstStyle/>
+          <a:p>
+            <a:pPr algn="ctr"/>
+            <a:r>
+              <a:rPr lang="en-US" altLang="zh-CN" dirty="0"/>
+              <a:t>RX1-MSG1</a:t>
+            </a:r>
+            <a:endParaRPr lang="zh-CN" altLang="en-US" dirty="0"/>
+          </a:p>
+        </p:txBody>
+      </p:sp>
+      <p:sp>
+        <p:nvSpPr>
+          <p:cNvPr id="27" name="流程图: 过程 26">
+            <a:extLst>
+              <a:ext uri="{FF2B5EF4-FFF2-40B4-BE49-F238E27FC236}">
+                <a16:creationId xmlns:a16="http://schemas.microsoft.com/office/drawing/2014/main" id="{BC603BCD-7202-99CE-F395-AD57A7F5FB3E}"/>
+              </a:ext>
+            </a:extLst>
+          </p:cNvPr>
+          <p:cNvSpPr/>
+          <p:nvPr/>
+        </p:nvSpPr>
+        <p:spPr>
+          <a:xfrm>
+            <a:off x="9232883" y="1543316"/>
+            <a:ext cx="1505632" cy="369332"/>
+          </a:xfrm>
+          <a:prstGeom prst="flowChartProcess">
+            <a:avLst/>
+          </a:prstGeom>
+        </p:spPr>
+        <p:style>
+          <a:lnRef idx="2">
+            <a:schemeClr val="accent1">
+              <a:shade val="15000"/>
+            </a:schemeClr>
+          </a:lnRef>
+          <a:fillRef idx="1">
+            <a:schemeClr val="accent1"/>
+          </a:fillRef>
+          <a:effectRef idx="0">
+            <a:schemeClr val="accent1"/>
+          </a:effectRef>
+          <a:fontRef idx="minor">
+            <a:schemeClr val="lt1"/>
+          </a:fontRef>
+        </p:style>
+        <p:txBody>
+          <a:bodyPr rtlCol="0" anchor="ctr"/>
+          <a:lstStyle/>
+          <a:p>
+            <a:pPr algn="ctr"/>
+            <a:r>
+              <a:rPr lang="en-US" altLang="zh-CN" dirty="0"/>
+              <a:t>RX1-MSG2</a:t>
+            </a:r>
+            <a:endParaRPr lang="zh-CN" altLang="en-US" dirty="0"/>
+          </a:p>
+        </p:txBody>
+      </p:sp>
+      <p:sp>
+        <p:nvSpPr>
+          <p:cNvPr id="28" name="流程图: 过程 27">
+            <a:extLst>
+              <a:ext uri="{FF2B5EF4-FFF2-40B4-BE49-F238E27FC236}">
+                <a16:creationId xmlns:a16="http://schemas.microsoft.com/office/drawing/2014/main" id="{38A59A7D-0851-388E-44D4-E7B19B55B72E}"/>
+              </a:ext>
+            </a:extLst>
+          </p:cNvPr>
+          <p:cNvSpPr/>
+          <p:nvPr/>
+        </p:nvSpPr>
+        <p:spPr>
+          <a:xfrm>
+            <a:off x="9232883" y="1929514"/>
+            <a:ext cx="1505632" cy="369332"/>
+          </a:xfrm>
+          <a:prstGeom prst="flowChartProcess">
+            <a:avLst/>
+          </a:prstGeom>
+        </p:spPr>
+        <p:style>
+          <a:lnRef idx="2">
+            <a:schemeClr val="accent1">
+              <a:shade val="15000"/>
+            </a:schemeClr>
+          </a:lnRef>
+          <a:fillRef idx="1">
+            <a:schemeClr val="accent1"/>
+          </a:fillRef>
+          <a:effectRef idx="0">
+            <a:schemeClr val="accent1"/>
+          </a:effectRef>
+          <a:fontRef idx="minor">
+            <a:schemeClr val="lt1"/>
+          </a:fontRef>
+        </p:style>
+        <p:txBody>
+          <a:bodyPr rtlCol="0" anchor="ctr"/>
+          <a:lstStyle/>
+          <a:p>
+            <a:pPr algn="ctr"/>
+            <a:r>
+              <a:rPr lang="en-US" altLang="zh-CN" dirty="0"/>
+              <a:t>RX1-MSG3</a:t>
+            </a:r>
+            <a:endParaRPr lang="zh-CN" altLang="en-US" dirty="0"/>
+          </a:p>
+        </p:txBody>
+      </p:sp>
+      <p:sp>
+        <p:nvSpPr>
+          <p:cNvPr id="29" name="流程图: 过程 28">
+            <a:extLst>
+              <a:ext uri="{FF2B5EF4-FFF2-40B4-BE49-F238E27FC236}">
+                <a16:creationId xmlns:a16="http://schemas.microsoft.com/office/drawing/2014/main" id="{11A24E88-332C-0520-0F5F-629D841EB9D4}"/>
+              </a:ext>
+            </a:extLst>
+          </p:cNvPr>
+          <p:cNvSpPr/>
+          <p:nvPr/>
+        </p:nvSpPr>
+        <p:spPr>
+          <a:xfrm>
+            <a:off x="9232883" y="2875627"/>
+            <a:ext cx="1505632" cy="369332"/>
+          </a:xfrm>
+          <a:prstGeom prst="flowChartProcess">
+            <a:avLst/>
+          </a:prstGeom>
+        </p:spPr>
+        <p:style>
+          <a:lnRef idx="2">
+            <a:schemeClr val="accent1">
+              <a:shade val="15000"/>
+            </a:schemeClr>
+          </a:lnRef>
+          <a:fillRef idx="1">
+            <a:schemeClr val="accent1"/>
+          </a:fillRef>
+          <a:effectRef idx="0">
+            <a:schemeClr val="accent1"/>
+          </a:effectRef>
+          <a:fontRef idx="minor">
+            <a:schemeClr val="lt1"/>
+          </a:fontRef>
+        </p:style>
+        <p:txBody>
+          <a:bodyPr rtlCol="0" anchor="ctr"/>
+          <a:lstStyle/>
+          <a:p>
+            <a:pPr algn="ctr"/>
+            <a:r>
+              <a:rPr lang="en-US" altLang="zh-CN" dirty="0"/>
+              <a:t>RX4-MSG0</a:t>
+            </a:r>
+            <a:endParaRPr lang="zh-CN" altLang="en-US" dirty="0"/>
+          </a:p>
+        </p:txBody>
+      </p:sp>
+      <p:sp>
+        <p:nvSpPr>
+          <p:cNvPr id="30" name="流程图: 过程 29">
+            <a:extLst>
+              <a:ext uri="{FF2B5EF4-FFF2-40B4-BE49-F238E27FC236}">
+                <a16:creationId xmlns:a16="http://schemas.microsoft.com/office/drawing/2014/main" id="{879B5D24-B17C-7C56-65D8-8904C9E5D869}"/>
+              </a:ext>
+            </a:extLst>
+          </p:cNvPr>
+          <p:cNvSpPr/>
+          <p:nvPr/>
+        </p:nvSpPr>
+        <p:spPr>
+          <a:xfrm>
+            <a:off x="9232883" y="3261824"/>
+            <a:ext cx="1505632" cy="369332"/>
+          </a:xfrm>
+          <a:prstGeom prst="flowChartProcess">
+            <a:avLst/>
+          </a:prstGeom>
+        </p:spPr>
+        <p:style>
+          <a:lnRef idx="2">
+            <a:schemeClr val="accent1">
+              <a:shade val="15000"/>
+            </a:schemeClr>
+          </a:lnRef>
+          <a:fillRef idx="1">
+            <a:schemeClr val="accent1"/>
+          </a:fillRef>
+          <a:effectRef idx="0">
+            <a:schemeClr val="accent1"/>
+          </a:effectRef>
+          <a:fontRef idx="minor">
+            <a:schemeClr val="lt1"/>
+          </a:fontRef>
+        </p:style>
+        <p:txBody>
+          <a:bodyPr rtlCol="0" anchor="ctr"/>
+          <a:lstStyle/>
+          <a:p>
+            <a:pPr algn="ctr"/>
+            <a:r>
+              <a:rPr lang="en-US" altLang="zh-CN" dirty="0"/>
+              <a:t>RX4-MSG1</a:t>
+            </a:r>
+            <a:endParaRPr lang="zh-CN" altLang="en-US" dirty="0"/>
+          </a:p>
+        </p:txBody>
+      </p:sp>
+      <p:sp>
+        <p:nvSpPr>
+          <p:cNvPr id="31" name="流程图: 过程 30">
+            <a:extLst>
+              <a:ext uri="{FF2B5EF4-FFF2-40B4-BE49-F238E27FC236}">
+                <a16:creationId xmlns:a16="http://schemas.microsoft.com/office/drawing/2014/main" id="{6695EA77-D3A5-EB00-59B6-787C8960DA2E}"/>
+              </a:ext>
+            </a:extLst>
+          </p:cNvPr>
+          <p:cNvSpPr/>
+          <p:nvPr/>
+        </p:nvSpPr>
+        <p:spPr>
+          <a:xfrm>
+            <a:off x="9232883" y="3648022"/>
+            <a:ext cx="1505632" cy="369332"/>
+          </a:xfrm>
+          <a:prstGeom prst="flowChartProcess">
+            <a:avLst/>
+          </a:prstGeom>
+        </p:spPr>
+        <p:style>
+          <a:lnRef idx="2">
+            <a:schemeClr val="accent1">
+              <a:shade val="15000"/>
+            </a:schemeClr>
+          </a:lnRef>
+          <a:fillRef idx="1">
+            <a:schemeClr val="accent1"/>
+          </a:fillRef>
+          <a:effectRef idx="0">
+            <a:schemeClr val="accent1"/>
+          </a:effectRef>
+          <a:fontRef idx="minor">
+            <a:schemeClr val="lt1"/>
+          </a:fontRef>
+        </p:style>
+        <p:txBody>
+          <a:bodyPr rtlCol="0" anchor="ctr"/>
+          <a:lstStyle/>
+          <a:p>
+            <a:pPr algn="ctr"/>
+            <a:r>
+              <a:rPr lang="en-US" altLang="zh-CN" dirty="0"/>
+              <a:t>RX4-MSG2</a:t>
+            </a:r>
+            <a:endParaRPr lang="zh-CN" altLang="en-US" dirty="0"/>
+          </a:p>
+        </p:txBody>
+      </p:sp>
+      <p:sp>
+        <p:nvSpPr>
+          <p:cNvPr id="32" name="流程图: 过程 31">
+            <a:extLst>
+              <a:ext uri="{FF2B5EF4-FFF2-40B4-BE49-F238E27FC236}">
+                <a16:creationId xmlns:a16="http://schemas.microsoft.com/office/drawing/2014/main" id="{79146F44-E04B-3287-A3E1-652E2B556478}"/>
+              </a:ext>
+            </a:extLst>
+          </p:cNvPr>
+          <p:cNvSpPr/>
+          <p:nvPr/>
+        </p:nvSpPr>
+        <p:spPr>
+          <a:xfrm>
+            <a:off x="9232883" y="4034220"/>
+            <a:ext cx="1505632" cy="369332"/>
+          </a:xfrm>
+          <a:prstGeom prst="flowChartProcess">
+            <a:avLst/>
+          </a:prstGeom>
+        </p:spPr>
+        <p:style>
+          <a:lnRef idx="2">
+            <a:schemeClr val="accent1">
+              <a:shade val="15000"/>
+            </a:schemeClr>
+          </a:lnRef>
+          <a:fillRef idx="1">
+            <a:schemeClr val="accent1"/>
+          </a:fillRef>
+          <a:effectRef idx="0">
+            <a:schemeClr val="accent1"/>
+          </a:effectRef>
+          <a:fontRef idx="minor">
+            <a:schemeClr val="lt1"/>
+          </a:fontRef>
+        </p:style>
+        <p:txBody>
+          <a:bodyPr rtlCol="0" anchor="ctr"/>
+          <a:lstStyle/>
+          <a:p>
+            <a:pPr algn="ctr"/>
+            <a:r>
+              <a:rPr lang="en-US" altLang="zh-CN" dirty="0"/>
+              <a:t>RX4-MSG3</a:t>
+            </a:r>
+            <a:endParaRPr lang="zh-CN" altLang="en-US" dirty="0"/>
+          </a:p>
+        </p:txBody>
+      </p:sp>
+      <p:sp>
+        <p:nvSpPr>
+          <p:cNvPr id="33" name="文本框 32">
+            <a:extLst>
+              <a:ext uri="{FF2B5EF4-FFF2-40B4-BE49-F238E27FC236}">
+                <a16:creationId xmlns:a16="http://schemas.microsoft.com/office/drawing/2014/main" id="{B37B293A-6735-3C80-8C32-753BE057C769}"/>
+              </a:ext>
+            </a:extLst>
+          </p:cNvPr>
+          <p:cNvSpPr txBox="1"/>
+          <p:nvPr/>
+        </p:nvSpPr>
+        <p:spPr>
+          <a:xfrm>
+            <a:off x="9812414" y="2356404"/>
+            <a:ext cx="434734" cy="461665"/>
+          </a:xfrm>
+          <a:prstGeom prst="rect">
+            <a:avLst/>
+          </a:prstGeom>
+          <a:noFill/>
+        </p:spPr>
+        <p:txBody>
+          <a:bodyPr wrap="none" rtlCol="0">
+            <a:spAutoFit/>
+          </a:bodyPr>
+          <a:lstStyle/>
+          <a:p>
+            <a:r>
+              <a:rPr lang="en-US" altLang="zh-CN" sz="2400" b="1" dirty="0"/>
+              <a:t>…</a:t>
+            </a:r>
+            <a:endParaRPr lang="zh-CN" altLang="en-US" b="1" dirty="0"/>
+          </a:p>
+        </p:txBody>
+      </p:sp>
     </p:spTree>
     <p:extLst>
       <p:ext uri="{BB962C8B-B14F-4D97-AF65-F5344CB8AC3E}">

</xml_diff>

<commit_message>
update eeprom module for page access
</commit_message>
<xml_diff>
--- a/stn/stn_test_fw_solution.pptx
+++ b/stn/stn_test_fw_solution.pptx
@@ -11709,712 +11709,1069 @@
           </p:style>
         </p:cxnSp>
       </p:grpSp>
-      <p:sp>
-        <p:nvSpPr>
-          <p:cNvPr id="3" name="文本框 2">
+      <p:grpSp>
+        <p:nvGrpSpPr>
+          <p:cNvPr id="50" name="组合 49">
             <a:extLst>
               <a:ext uri="{FF2B5EF4-FFF2-40B4-BE49-F238E27FC236}">
-                <a16:creationId xmlns:a16="http://schemas.microsoft.com/office/drawing/2014/main" id="{FF9340DA-28C2-D53D-A421-AB943919EBC5}"/>
+                <a16:creationId xmlns:a16="http://schemas.microsoft.com/office/drawing/2014/main" id="{DBD9FD30-8466-357B-6B16-33D073E41C3E}"/>
               </a:ext>
             </a:extLst>
           </p:cNvPr>
-          <p:cNvSpPr txBox="1"/>
+          <p:cNvGrpSpPr/>
           <p:nvPr/>
-        </p:nvSpPr>
-        <p:spPr>
+        </p:nvGrpSpPr>
+        <p:grpSpPr>
           <a:xfrm>
-            <a:off x="6258412" y="353176"/>
-            <a:ext cx="1207698" cy="369332"/>
+            <a:off x="6017263" y="353176"/>
+            <a:ext cx="4721252" cy="4050376"/>
+            <a:chOff x="6017263" y="353176"/>
+            <a:chExt cx="4721252" cy="4050376"/>
           </a:xfrm>
-          <a:prstGeom prst="rect">
-            <a:avLst/>
-          </a:prstGeom>
-          <a:noFill/>
-        </p:spPr>
-        <p:txBody>
-          <a:bodyPr wrap="square" rtlCol="0">
-            <a:spAutoFit/>
-          </a:bodyPr>
-          <a:lstStyle/>
-          <a:p>
-            <a:r>
-              <a:rPr lang="en-US" altLang="zh-CN" b="1" dirty="0"/>
-              <a:t>CAN TX</a:t>
-            </a:r>
-          </a:p>
-        </p:txBody>
-      </p:sp>
-      <p:sp>
-        <p:nvSpPr>
-          <p:cNvPr id="13" name="流程图: 过程 12">
-            <a:extLst>
-              <a:ext uri="{FF2B5EF4-FFF2-40B4-BE49-F238E27FC236}">
-                <a16:creationId xmlns:a16="http://schemas.microsoft.com/office/drawing/2014/main" id="{5C8A793E-FB00-6DBF-ECB9-ACE3D0E9B9DE}"/>
-              </a:ext>
-            </a:extLst>
-          </p:cNvPr>
-          <p:cNvSpPr/>
-          <p:nvPr/>
-        </p:nvSpPr>
-        <p:spPr>
-          <a:xfrm>
-            <a:off x="6017263" y="787786"/>
-            <a:ext cx="1505632" cy="369332"/>
-          </a:xfrm>
-          <a:prstGeom prst="flowChartProcess">
-            <a:avLst/>
-          </a:prstGeom>
-        </p:spPr>
-        <p:style>
-          <a:lnRef idx="2">
-            <a:schemeClr val="accent1">
-              <a:shade val="15000"/>
-            </a:schemeClr>
-          </a:lnRef>
-          <a:fillRef idx="1">
-            <a:schemeClr val="accent1"/>
-          </a:fillRef>
-          <a:effectRef idx="0">
-            <a:schemeClr val="accent1"/>
-          </a:effectRef>
-          <a:fontRef idx="minor">
-            <a:schemeClr val="lt1"/>
-          </a:fontRef>
-        </p:style>
-        <p:txBody>
-          <a:bodyPr rtlCol="0" anchor="ctr"/>
-          <a:lstStyle/>
-          <a:p>
-            <a:pPr algn="ctr"/>
-            <a:r>
-              <a:rPr lang="en-US" altLang="zh-CN" dirty="0"/>
-              <a:t>TX1-MSG0</a:t>
-            </a:r>
-            <a:endParaRPr lang="zh-CN" altLang="en-US" dirty="0"/>
-          </a:p>
-        </p:txBody>
-      </p:sp>
-      <p:sp>
-        <p:nvSpPr>
-          <p:cNvPr id="15" name="流程图: 过程 14">
-            <a:extLst>
-              <a:ext uri="{FF2B5EF4-FFF2-40B4-BE49-F238E27FC236}">
-                <a16:creationId xmlns:a16="http://schemas.microsoft.com/office/drawing/2014/main" id="{B1F57041-7331-5476-C040-61C610E4152A}"/>
-              </a:ext>
-            </a:extLst>
-          </p:cNvPr>
-          <p:cNvSpPr/>
-          <p:nvPr/>
-        </p:nvSpPr>
-        <p:spPr>
-          <a:xfrm>
-            <a:off x="6017263" y="1759943"/>
-            <a:ext cx="1505632" cy="369332"/>
-          </a:xfrm>
-          <a:prstGeom prst="flowChartProcess">
-            <a:avLst/>
-          </a:prstGeom>
-        </p:spPr>
-        <p:style>
-          <a:lnRef idx="2">
-            <a:schemeClr val="accent1">
-              <a:shade val="15000"/>
-            </a:schemeClr>
-          </a:lnRef>
-          <a:fillRef idx="1">
-            <a:schemeClr val="accent1"/>
-          </a:fillRef>
-          <a:effectRef idx="0">
-            <a:schemeClr val="accent1"/>
-          </a:effectRef>
-          <a:fontRef idx="minor">
-            <a:schemeClr val="lt1"/>
-          </a:fontRef>
-        </p:style>
-        <p:txBody>
-          <a:bodyPr rtlCol="0" anchor="ctr"/>
-          <a:lstStyle/>
-          <a:p>
-            <a:pPr algn="ctr"/>
-            <a:r>
-              <a:rPr lang="en-US" altLang="zh-CN" dirty="0"/>
-              <a:t>TX2-MSG0</a:t>
-            </a:r>
-            <a:endParaRPr lang="zh-CN" altLang="en-US" dirty="0"/>
-          </a:p>
-        </p:txBody>
-      </p:sp>
-      <p:sp>
-        <p:nvSpPr>
-          <p:cNvPr id="17" name="流程图: 过程 16">
-            <a:extLst>
-              <a:ext uri="{FF2B5EF4-FFF2-40B4-BE49-F238E27FC236}">
-                <a16:creationId xmlns:a16="http://schemas.microsoft.com/office/drawing/2014/main" id="{F116CB81-E850-96ED-C0FF-46D40081688B}"/>
-              </a:ext>
-            </a:extLst>
-          </p:cNvPr>
-          <p:cNvSpPr/>
-          <p:nvPr/>
-        </p:nvSpPr>
-        <p:spPr>
-          <a:xfrm>
-            <a:off x="6017263" y="2732100"/>
-            <a:ext cx="1505632" cy="326746"/>
-          </a:xfrm>
-          <a:prstGeom prst="flowChartProcess">
-            <a:avLst/>
-          </a:prstGeom>
-        </p:spPr>
-        <p:style>
-          <a:lnRef idx="2">
-            <a:schemeClr val="accent1">
-              <a:shade val="15000"/>
-            </a:schemeClr>
-          </a:lnRef>
-          <a:fillRef idx="1">
-            <a:schemeClr val="accent1"/>
-          </a:fillRef>
-          <a:effectRef idx="0">
-            <a:schemeClr val="accent1"/>
-          </a:effectRef>
-          <a:fontRef idx="minor">
-            <a:schemeClr val="lt1"/>
-          </a:fontRef>
-        </p:style>
-        <p:txBody>
-          <a:bodyPr rtlCol="0" anchor="ctr"/>
-          <a:lstStyle/>
-          <a:p>
-            <a:pPr algn="ctr"/>
-            <a:r>
-              <a:rPr lang="en-US" altLang="zh-CN" dirty="0"/>
-              <a:t>TX3-MSG0</a:t>
-            </a:r>
-            <a:endParaRPr lang="zh-CN" altLang="en-US" dirty="0"/>
-          </a:p>
-        </p:txBody>
-      </p:sp>
-      <p:sp>
-        <p:nvSpPr>
-          <p:cNvPr id="19" name="流程图: 过程 18">
-            <a:extLst>
-              <a:ext uri="{FF2B5EF4-FFF2-40B4-BE49-F238E27FC236}">
-                <a16:creationId xmlns:a16="http://schemas.microsoft.com/office/drawing/2014/main" id="{83860E17-F0D5-3A7B-1150-B5FA0D474E7D}"/>
-              </a:ext>
-            </a:extLst>
-          </p:cNvPr>
-          <p:cNvSpPr/>
-          <p:nvPr/>
-        </p:nvSpPr>
-        <p:spPr>
-          <a:xfrm>
-            <a:off x="6017263" y="3661670"/>
-            <a:ext cx="1505632" cy="326746"/>
-          </a:xfrm>
-          <a:prstGeom prst="flowChartProcess">
-            <a:avLst/>
-          </a:prstGeom>
-        </p:spPr>
-        <p:style>
-          <a:lnRef idx="2">
-            <a:schemeClr val="accent1">
-              <a:shade val="15000"/>
-            </a:schemeClr>
-          </a:lnRef>
-          <a:fillRef idx="1">
-            <a:schemeClr val="accent1"/>
-          </a:fillRef>
-          <a:effectRef idx="0">
-            <a:schemeClr val="accent1"/>
-          </a:effectRef>
-          <a:fontRef idx="minor">
-            <a:schemeClr val="lt1"/>
-          </a:fontRef>
-        </p:style>
-        <p:txBody>
-          <a:bodyPr rtlCol="0" anchor="ctr"/>
-          <a:lstStyle/>
-          <a:p>
-            <a:pPr algn="ctr"/>
-            <a:r>
-              <a:rPr lang="en-US" altLang="zh-CN" dirty="0"/>
-              <a:t>TX4-MSG0</a:t>
-            </a:r>
-            <a:endParaRPr lang="zh-CN" altLang="en-US" dirty="0"/>
-          </a:p>
-        </p:txBody>
-      </p:sp>
-      <p:sp>
-        <p:nvSpPr>
-          <p:cNvPr id="22" name="文本框 21">
-            <a:extLst>
-              <a:ext uri="{FF2B5EF4-FFF2-40B4-BE49-F238E27FC236}">
-                <a16:creationId xmlns:a16="http://schemas.microsoft.com/office/drawing/2014/main" id="{556E670A-2A49-911F-9E6F-A89B4509CB0A}"/>
-              </a:ext>
-            </a:extLst>
-          </p:cNvPr>
-          <p:cNvSpPr txBox="1"/>
-          <p:nvPr/>
-        </p:nvSpPr>
-        <p:spPr>
-          <a:xfrm>
-            <a:off x="9381850" y="353176"/>
-            <a:ext cx="1207698" cy="369332"/>
-          </a:xfrm>
-          <a:prstGeom prst="rect">
-            <a:avLst/>
-          </a:prstGeom>
-          <a:noFill/>
-        </p:spPr>
-        <p:txBody>
-          <a:bodyPr wrap="square" rtlCol="0">
-            <a:spAutoFit/>
-          </a:bodyPr>
-          <a:lstStyle/>
-          <a:p>
-            <a:r>
-              <a:rPr lang="en-US" altLang="zh-CN" b="1" dirty="0"/>
-              <a:t>CAN RX</a:t>
-            </a:r>
-          </a:p>
-        </p:txBody>
-      </p:sp>
-      <p:sp>
-        <p:nvSpPr>
-          <p:cNvPr id="25" name="流程图: 过程 24">
-            <a:extLst>
-              <a:ext uri="{FF2B5EF4-FFF2-40B4-BE49-F238E27FC236}">
-                <a16:creationId xmlns:a16="http://schemas.microsoft.com/office/drawing/2014/main" id="{06F6D7FC-34A1-A141-8AEF-F4FF0F98CF06}"/>
-              </a:ext>
-            </a:extLst>
-          </p:cNvPr>
-          <p:cNvSpPr/>
-          <p:nvPr/>
-        </p:nvSpPr>
-        <p:spPr>
-          <a:xfrm>
-            <a:off x="9232883" y="770921"/>
-            <a:ext cx="1505632" cy="369332"/>
-          </a:xfrm>
-          <a:prstGeom prst="flowChartProcess">
-            <a:avLst/>
-          </a:prstGeom>
-        </p:spPr>
-        <p:style>
-          <a:lnRef idx="2">
-            <a:schemeClr val="accent1">
-              <a:shade val="15000"/>
-            </a:schemeClr>
-          </a:lnRef>
-          <a:fillRef idx="1">
-            <a:schemeClr val="accent1"/>
-          </a:fillRef>
-          <a:effectRef idx="0">
-            <a:schemeClr val="accent1"/>
-          </a:effectRef>
-          <a:fontRef idx="minor">
-            <a:schemeClr val="lt1"/>
-          </a:fontRef>
-        </p:style>
-        <p:txBody>
-          <a:bodyPr rtlCol="0" anchor="ctr"/>
-          <a:lstStyle/>
-          <a:p>
-            <a:pPr algn="ctr"/>
-            <a:r>
-              <a:rPr lang="en-US" altLang="zh-CN" dirty="0"/>
-              <a:t>RX1-MSG0</a:t>
-            </a:r>
-            <a:endParaRPr lang="zh-CN" altLang="en-US" dirty="0"/>
-          </a:p>
-        </p:txBody>
-      </p:sp>
-      <p:sp>
-        <p:nvSpPr>
-          <p:cNvPr id="26" name="流程图: 过程 25">
-            <a:extLst>
-              <a:ext uri="{FF2B5EF4-FFF2-40B4-BE49-F238E27FC236}">
-                <a16:creationId xmlns:a16="http://schemas.microsoft.com/office/drawing/2014/main" id="{D7CD7E09-CFC8-E4C5-0DFB-1751F26EB582}"/>
-              </a:ext>
-            </a:extLst>
-          </p:cNvPr>
-          <p:cNvSpPr/>
-          <p:nvPr/>
-        </p:nvSpPr>
-        <p:spPr>
-          <a:xfrm>
-            <a:off x="9232883" y="1157118"/>
-            <a:ext cx="1505632" cy="369332"/>
-          </a:xfrm>
-          <a:prstGeom prst="flowChartProcess">
-            <a:avLst/>
-          </a:prstGeom>
-        </p:spPr>
-        <p:style>
-          <a:lnRef idx="2">
-            <a:schemeClr val="accent1">
-              <a:shade val="15000"/>
-            </a:schemeClr>
-          </a:lnRef>
-          <a:fillRef idx="1">
-            <a:schemeClr val="accent1"/>
-          </a:fillRef>
-          <a:effectRef idx="0">
-            <a:schemeClr val="accent1"/>
-          </a:effectRef>
-          <a:fontRef idx="minor">
-            <a:schemeClr val="lt1"/>
-          </a:fontRef>
-        </p:style>
-        <p:txBody>
-          <a:bodyPr rtlCol="0" anchor="ctr"/>
-          <a:lstStyle/>
-          <a:p>
-            <a:pPr algn="ctr"/>
-            <a:r>
-              <a:rPr lang="en-US" altLang="zh-CN" dirty="0"/>
-              <a:t>RX1-MSG1</a:t>
-            </a:r>
-            <a:endParaRPr lang="zh-CN" altLang="en-US" dirty="0"/>
-          </a:p>
-        </p:txBody>
-      </p:sp>
-      <p:sp>
-        <p:nvSpPr>
-          <p:cNvPr id="27" name="流程图: 过程 26">
-            <a:extLst>
-              <a:ext uri="{FF2B5EF4-FFF2-40B4-BE49-F238E27FC236}">
-                <a16:creationId xmlns:a16="http://schemas.microsoft.com/office/drawing/2014/main" id="{BC603BCD-7202-99CE-F395-AD57A7F5FB3E}"/>
-              </a:ext>
-            </a:extLst>
-          </p:cNvPr>
-          <p:cNvSpPr/>
-          <p:nvPr/>
-        </p:nvSpPr>
-        <p:spPr>
-          <a:xfrm>
-            <a:off x="9232883" y="1543316"/>
-            <a:ext cx="1505632" cy="369332"/>
-          </a:xfrm>
-          <a:prstGeom prst="flowChartProcess">
-            <a:avLst/>
-          </a:prstGeom>
-        </p:spPr>
-        <p:style>
-          <a:lnRef idx="2">
-            <a:schemeClr val="accent1">
-              <a:shade val="15000"/>
-            </a:schemeClr>
-          </a:lnRef>
-          <a:fillRef idx="1">
-            <a:schemeClr val="accent1"/>
-          </a:fillRef>
-          <a:effectRef idx="0">
-            <a:schemeClr val="accent1"/>
-          </a:effectRef>
-          <a:fontRef idx="minor">
-            <a:schemeClr val="lt1"/>
-          </a:fontRef>
-        </p:style>
-        <p:txBody>
-          <a:bodyPr rtlCol="0" anchor="ctr"/>
-          <a:lstStyle/>
-          <a:p>
-            <a:pPr algn="ctr"/>
-            <a:r>
-              <a:rPr lang="en-US" altLang="zh-CN" dirty="0"/>
-              <a:t>RX1-MSG2</a:t>
-            </a:r>
-            <a:endParaRPr lang="zh-CN" altLang="en-US" dirty="0"/>
-          </a:p>
-        </p:txBody>
-      </p:sp>
-      <p:sp>
-        <p:nvSpPr>
-          <p:cNvPr id="28" name="流程图: 过程 27">
-            <a:extLst>
-              <a:ext uri="{FF2B5EF4-FFF2-40B4-BE49-F238E27FC236}">
-                <a16:creationId xmlns:a16="http://schemas.microsoft.com/office/drawing/2014/main" id="{38A59A7D-0851-388E-44D4-E7B19B55B72E}"/>
-              </a:ext>
-            </a:extLst>
-          </p:cNvPr>
-          <p:cNvSpPr/>
-          <p:nvPr/>
-        </p:nvSpPr>
-        <p:spPr>
-          <a:xfrm>
-            <a:off x="9232883" y="1929514"/>
-            <a:ext cx="1505632" cy="369332"/>
-          </a:xfrm>
-          <a:prstGeom prst="flowChartProcess">
-            <a:avLst/>
-          </a:prstGeom>
-        </p:spPr>
-        <p:style>
-          <a:lnRef idx="2">
-            <a:schemeClr val="accent1">
-              <a:shade val="15000"/>
-            </a:schemeClr>
-          </a:lnRef>
-          <a:fillRef idx="1">
-            <a:schemeClr val="accent1"/>
-          </a:fillRef>
-          <a:effectRef idx="0">
-            <a:schemeClr val="accent1"/>
-          </a:effectRef>
-          <a:fontRef idx="minor">
-            <a:schemeClr val="lt1"/>
-          </a:fontRef>
-        </p:style>
-        <p:txBody>
-          <a:bodyPr rtlCol="0" anchor="ctr"/>
-          <a:lstStyle/>
-          <a:p>
-            <a:pPr algn="ctr"/>
-            <a:r>
-              <a:rPr lang="en-US" altLang="zh-CN" dirty="0"/>
-              <a:t>RX1-MSG3</a:t>
-            </a:r>
-            <a:endParaRPr lang="zh-CN" altLang="en-US" dirty="0"/>
-          </a:p>
-        </p:txBody>
-      </p:sp>
-      <p:sp>
-        <p:nvSpPr>
-          <p:cNvPr id="29" name="流程图: 过程 28">
-            <a:extLst>
-              <a:ext uri="{FF2B5EF4-FFF2-40B4-BE49-F238E27FC236}">
-                <a16:creationId xmlns:a16="http://schemas.microsoft.com/office/drawing/2014/main" id="{11A24E88-332C-0520-0F5F-629D841EB9D4}"/>
-              </a:ext>
-            </a:extLst>
-          </p:cNvPr>
-          <p:cNvSpPr/>
-          <p:nvPr/>
-        </p:nvSpPr>
-        <p:spPr>
-          <a:xfrm>
-            <a:off x="9232883" y="2875627"/>
-            <a:ext cx="1505632" cy="369332"/>
-          </a:xfrm>
-          <a:prstGeom prst="flowChartProcess">
-            <a:avLst/>
-          </a:prstGeom>
-        </p:spPr>
-        <p:style>
-          <a:lnRef idx="2">
-            <a:schemeClr val="accent1">
-              <a:shade val="15000"/>
-            </a:schemeClr>
-          </a:lnRef>
-          <a:fillRef idx="1">
-            <a:schemeClr val="accent1"/>
-          </a:fillRef>
-          <a:effectRef idx="0">
-            <a:schemeClr val="accent1"/>
-          </a:effectRef>
-          <a:fontRef idx="minor">
-            <a:schemeClr val="lt1"/>
-          </a:fontRef>
-        </p:style>
-        <p:txBody>
-          <a:bodyPr rtlCol="0" anchor="ctr"/>
-          <a:lstStyle/>
-          <a:p>
-            <a:pPr algn="ctr"/>
-            <a:r>
-              <a:rPr lang="en-US" altLang="zh-CN" dirty="0"/>
-              <a:t>RX4-MSG0</a:t>
-            </a:r>
-            <a:endParaRPr lang="zh-CN" altLang="en-US" dirty="0"/>
-          </a:p>
-        </p:txBody>
-      </p:sp>
-      <p:sp>
-        <p:nvSpPr>
-          <p:cNvPr id="30" name="流程图: 过程 29">
-            <a:extLst>
-              <a:ext uri="{FF2B5EF4-FFF2-40B4-BE49-F238E27FC236}">
-                <a16:creationId xmlns:a16="http://schemas.microsoft.com/office/drawing/2014/main" id="{879B5D24-B17C-7C56-65D8-8904C9E5D869}"/>
-              </a:ext>
-            </a:extLst>
-          </p:cNvPr>
-          <p:cNvSpPr/>
-          <p:nvPr/>
-        </p:nvSpPr>
-        <p:spPr>
-          <a:xfrm>
-            <a:off x="9232883" y="3261824"/>
-            <a:ext cx="1505632" cy="369332"/>
-          </a:xfrm>
-          <a:prstGeom prst="flowChartProcess">
-            <a:avLst/>
-          </a:prstGeom>
-        </p:spPr>
-        <p:style>
-          <a:lnRef idx="2">
-            <a:schemeClr val="accent1">
-              <a:shade val="15000"/>
-            </a:schemeClr>
-          </a:lnRef>
-          <a:fillRef idx="1">
-            <a:schemeClr val="accent1"/>
-          </a:fillRef>
-          <a:effectRef idx="0">
-            <a:schemeClr val="accent1"/>
-          </a:effectRef>
-          <a:fontRef idx="minor">
-            <a:schemeClr val="lt1"/>
-          </a:fontRef>
-        </p:style>
-        <p:txBody>
-          <a:bodyPr rtlCol="0" anchor="ctr"/>
-          <a:lstStyle/>
-          <a:p>
-            <a:pPr algn="ctr"/>
-            <a:r>
-              <a:rPr lang="en-US" altLang="zh-CN" dirty="0"/>
-              <a:t>RX4-MSG1</a:t>
-            </a:r>
-            <a:endParaRPr lang="zh-CN" altLang="en-US" dirty="0"/>
-          </a:p>
-        </p:txBody>
-      </p:sp>
-      <p:sp>
-        <p:nvSpPr>
-          <p:cNvPr id="31" name="流程图: 过程 30">
-            <a:extLst>
-              <a:ext uri="{FF2B5EF4-FFF2-40B4-BE49-F238E27FC236}">
-                <a16:creationId xmlns:a16="http://schemas.microsoft.com/office/drawing/2014/main" id="{6695EA77-D3A5-EB00-59B6-787C8960DA2E}"/>
-              </a:ext>
-            </a:extLst>
-          </p:cNvPr>
-          <p:cNvSpPr/>
-          <p:nvPr/>
-        </p:nvSpPr>
-        <p:spPr>
-          <a:xfrm>
-            <a:off x="9232883" y="3648022"/>
-            <a:ext cx="1505632" cy="369332"/>
-          </a:xfrm>
-          <a:prstGeom prst="flowChartProcess">
-            <a:avLst/>
-          </a:prstGeom>
-        </p:spPr>
-        <p:style>
-          <a:lnRef idx="2">
-            <a:schemeClr val="accent1">
-              <a:shade val="15000"/>
-            </a:schemeClr>
-          </a:lnRef>
-          <a:fillRef idx="1">
-            <a:schemeClr val="accent1"/>
-          </a:fillRef>
-          <a:effectRef idx="0">
-            <a:schemeClr val="accent1"/>
-          </a:effectRef>
-          <a:fontRef idx="minor">
-            <a:schemeClr val="lt1"/>
-          </a:fontRef>
-        </p:style>
-        <p:txBody>
-          <a:bodyPr rtlCol="0" anchor="ctr"/>
-          <a:lstStyle/>
-          <a:p>
-            <a:pPr algn="ctr"/>
-            <a:r>
-              <a:rPr lang="en-US" altLang="zh-CN" dirty="0"/>
-              <a:t>RX4-MSG2</a:t>
-            </a:r>
-            <a:endParaRPr lang="zh-CN" altLang="en-US" dirty="0"/>
-          </a:p>
-        </p:txBody>
-      </p:sp>
-      <p:sp>
-        <p:nvSpPr>
-          <p:cNvPr id="32" name="流程图: 过程 31">
-            <a:extLst>
-              <a:ext uri="{FF2B5EF4-FFF2-40B4-BE49-F238E27FC236}">
-                <a16:creationId xmlns:a16="http://schemas.microsoft.com/office/drawing/2014/main" id="{79146F44-E04B-3287-A3E1-652E2B556478}"/>
-              </a:ext>
-            </a:extLst>
-          </p:cNvPr>
-          <p:cNvSpPr/>
-          <p:nvPr/>
-        </p:nvSpPr>
-        <p:spPr>
-          <a:xfrm>
-            <a:off x="9232883" y="4034220"/>
-            <a:ext cx="1505632" cy="369332"/>
-          </a:xfrm>
-          <a:prstGeom prst="flowChartProcess">
-            <a:avLst/>
-          </a:prstGeom>
-        </p:spPr>
-        <p:style>
-          <a:lnRef idx="2">
-            <a:schemeClr val="accent1">
-              <a:shade val="15000"/>
-            </a:schemeClr>
-          </a:lnRef>
-          <a:fillRef idx="1">
-            <a:schemeClr val="accent1"/>
-          </a:fillRef>
-          <a:effectRef idx="0">
-            <a:schemeClr val="accent1"/>
-          </a:effectRef>
-          <a:fontRef idx="minor">
-            <a:schemeClr val="lt1"/>
-          </a:fontRef>
-        </p:style>
-        <p:txBody>
-          <a:bodyPr rtlCol="0" anchor="ctr"/>
-          <a:lstStyle/>
-          <a:p>
-            <a:pPr algn="ctr"/>
-            <a:r>
-              <a:rPr lang="en-US" altLang="zh-CN" dirty="0"/>
-              <a:t>RX4-MSG3</a:t>
-            </a:r>
-            <a:endParaRPr lang="zh-CN" altLang="en-US" dirty="0"/>
-          </a:p>
-        </p:txBody>
-      </p:sp>
-      <p:sp>
-        <p:nvSpPr>
-          <p:cNvPr id="33" name="文本框 32">
-            <a:extLst>
-              <a:ext uri="{FF2B5EF4-FFF2-40B4-BE49-F238E27FC236}">
-                <a16:creationId xmlns:a16="http://schemas.microsoft.com/office/drawing/2014/main" id="{B37B293A-6735-3C80-8C32-753BE057C769}"/>
-              </a:ext>
-            </a:extLst>
-          </p:cNvPr>
-          <p:cNvSpPr txBox="1"/>
-          <p:nvPr/>
-        </p:nvSpPr>
-        <p:spPr>
-          <a:xfrm>
-            <a:off x="9812414" y="2356404"/>
-            <a:ext cx="434734" cy="461665"/>
-          </a:xfrm>
-          <a:prstGeom prst="rect">
-            <a:avLst/>
-          </a:prstGeom>
-          <a:noFill/>
-        </p:spPr>
-        <p:txBody>
-          <a:bodyPr wrap="none" rtlCol="0">
-            <a:spAutoFit/>
-          </a:bodyPr>
-          <a:lstStyle/>
-          <a:p>
-            <a:r>
-              <a:rPr lang="en-US" altLang="zh-CN" sz="2400" b="1" dirty="0"/>
-              <a:t>…</a:t>
-            </a:r>
-            <a:endParaRPr lang="zh-CN" altLang="en-US" b="1" dirty="0"/>
-          </a:p>
-        </p:txBody>
-      </p:sp>
+        </p:grpSpPr>
+        <p:sp>
+          <p:nvSpPr>
+            <p:cNvPr id="3" name="文本框 2">
+              <a:extLst>
+                <a:ext uri="{FF2B5EF4-FFF2-40B4-BE49-F238E27FC236}">
+                  <a16:creationId xmlns:a16="http://schemas.microsoft.com/office/drawing/2014/main" id="{FF9340DA-28C2-D53D-A421-AB943919EBC5}"/>
+                </a:ext>
+              </a:extLst>
+            </p:cNvPr>
+            <p:cNvSpPr txBox="1"/>
+            <p:nvPr/>
+          </p:nvSpPr>
+          <p:spPr>
+            <a:xfrm>
+              <a:off x="6258412" y="353176"/>
+              <a:ext cx="1207698" cy="369332"/>
+            </a:xfrm>
+            <a:prstGeom prst="rect">
+              <a:avLst/>
+            </a:prstGeom>
+            <a:noFill/>
+          </p:spPr>
+          <p:txBody>
+            <a:bodyPr wrap="square" rtlCol="0">
+              <a:spAutoFit/>
+            </a:bodyPr>
+            <a:lstStyle/>
+            <a:p>
+              <a:r>
+                <a:rPr lang="en-US" altLang="zh-CN" b="1" dirty="0"/>
+                <a:t>CAN TX</a:t>
+              </a:r>
+            </a:p>
+          </p:txBody>
+        </p:sp>
+        <p:sp>
+          <p:nvSpPr>
+            <p:cNvPr id="13" name="流程图: 过程 12">
+              <a:extLst>
+                <a:ext uri="{FF2B5EF4-FFF2-40B4-BE49-F238E27FC236}">
+                  <a16:creationId xmlns:a16="http://schemas.microsoft.com/office/drawing/2014/main" id="{5C8A793E-FB00-6DBF-ECB9-ACE3D0E9B9DE}"/>
+                </a:ext>
+              </a:extLst>
+            </p:cNvPr>
+            <p:cNvSpPr/>
+            <p:nvPr/>
+          </p:nvSpPr>
+          <p:spPr>
+            <a:xfrm>
+              <a:off x="6017263" y="787786"/>
+              <a:ext cx="1505632" cy="369332"/>
+            </a:xfrm>
+            <a:prstGeom prst="flowChartProcess">
+              <a:avLst/>
+            </a:prstGeom>
+          </p:spPr>
+          <p:style>
+            <a:lnRef idx="2">
+              <a:schemeClr val="accent1">
+                <a:shade val="15000"/>
+              </a:schemeClr>
+            </a:lnRef>
+            <a:fillRef idx="1">
+              <a:schemeClr val="accent1"/>
+            </a:fillRef>
+            <a:effectRef idx="0">
+              <a:schemeClr val="accent1"/>
+            </a:effectRef>
+            <a:fontRef idx="minor">
+              <a:schemeClr val="lt1"/>
+            </a:fontRef>
+          </p:style>
+          <p:txBody>
+            <a:bodyPr rtlCol="0" anchor="ctr"/>
+            <a:lstStyle/>
+            <a:p>
+              <a:pPr algn="ctr"/>
+              <a:r>
+                <a:rPr lang="en-US" altLang="zh-CN" dirty="0"/>
+                <a:t>TX1-MSG0</a:t>
+              </a:r>
+              <a:endParaRPr lang="zh-CN" altLang="en-US" dirty="0"/>
+            </a:p>
+          </p:txBody>
+        </p:sp>
+        <p:sp>
+          <p:nvSpPr>
+            <p:cNvPr id="15" name="流程图: 过程 14">
+              <a:extLst>
+                <a:ext uri="{FF2B5EF4-FFF2-40B4-BE49-F238E27FC236}">
+                  <a16:creationId xmlns:a16="http://schemas.microsoft.com/office/drawing/2014/main" id="{B1F57041-7331-5476-C040-61C610E4152A}"/>
+                </a:ext>
+              </a:extLst>
+            </p:cNvPr>
+            <p:cNvSpPr/>
+            <p:nvPr/>
+          </p:nvSpPr>
+          <p:spPr>
+            <a:xfrm>
+              <a:off x="6017263" y="1759943"/>
+              <a:ext cx="1505632" cy="369332"/>
+            </a:xfrm>
+            <a:prstGeom prst="flowChartProcess">
+              <a:avLst/>
+            </a:prstGeom>
+          </p:spPr>
+          <p:style>
+            <a:lnRef idx="2">
+              <a:schemeClr val="accent1">
+                <a:shade val="15000"/>
+              </a:schemeClr>
+            </a:lnRef>
+            <a:fillRef idx="1">
+              <a:schemeClr val="accent1"/>
+            </a:fillRef>
+            <a:effectRef idx="0">
+              <a:schemeClr val="accent1"/>
+            </a:effectRef>
+            <a:fontRef idx="minor">
+              <a:schemeClr val="lt1"/>
+            </a:fontRef>
+          </p:style>
+          <p:txBody>
+            <a:bodyPr rtlCol="0" anchor="ctr"/>
+            <a:lstStyle/>
+            <a:p>
+              <a:pPr algn="ctr"/>
+              <a:r>
+                <a:rPr lang="en-US" altLang="zh-CN" dirty="0"/>
+                <a:t>TX2-MSG0</a:t>
+              </a:r>
+              <a:endParaRPr lang="zh-CN" altLang="en-US" dirty="0"/>
+            </a:p>
+          </p:txBody>
+        </p:sp>
+        <p:sp>
+          <p:nvSpPr>
+            <p:cNvPr id="17" name="流程图: 过程 16">
+              <a:extLst>
+                <a:ext uri="{FF2B5EF4-FFF2-40B4-BE49-F238E27FC236}">
+                  <a16:creationId xmlns:a16="http://schemas.microsoft.com/office/drawing/2014/main" id="{F116CB81-E850-96ED-C0FF-46D40081688B}"/>
+                </a:ext>
+              </a:extLst>
+            </p:cNvPr>
+            <p:cNvSpPr/>
+            <p:nvPr/>
+          </p:nvSpPr>
+          <p:spPr>
+            <a:xfrm>
+              <a:off x="6017263" y="2732100"/>
+              <a:ext cx="1505632" cy="326746"/>
+            </a:xfrm>
+            <a:prstGeom prst="flowChartProcess">
+              <a:avLst/>
+            </a:prstGeom>
+          </p:spPr>
+          <p:style>
+            <a:lnRef idx="2">
+              <a:schemeClr val="accent1">
+                <a:shade val="15000"/>
+              </a:schemeClr>
+            </a:lnRef>
+            <a:fillRef idx="1">
+              <a:schemeClr val="accent1"/>
+            </a:fillRef>
+            <a:effectRef idx="0">
+              <a:schemeClr val="accent1"/>
+            </a:effectRef>
+            <a:fontRef idx="minor">
+              <a:schemeClr val="lt1"/>
+            </a:fontRef>
+          </p:style>
+          <p:txBody>
+            <a:bodyPr rtlCol="0" anchor="ctr"/>
+            <a:lstStyle/>
+            <a:p>
+              <a:pPr algn="ctr"/>
+              <a:r>
+                <a:rPr lang="en-US" altLang="zh-CN" dirty="0"/>
+                <a:t>TX3-MSG0</a:t>
+              </a:r>
+              <a:endParaRPr lang="zh-CN" altLang="en-US" dirty="0"/>
+            </a:p>
+          </p:txBody>
+        </p:sp>
+        <p:sp>
+          <p:nvSpPr>
+            <p:cNvPr id="19" name="流程图: 过程 18">
+              <a:extLst>
+                <a:ext uri="{FF2B5EF4-FFF2-40B4-BE49-F238E27FC236}">
+                  <a16:creationId xmlns:a16="http://schemas.microsoft.com/office/drawing/2014/main" id="{83860E17-F0D5-3A7B-1150-B5FA0D474E7D}"/>
+                </a:ext>
+              </a:extLst>
+            </p:cNvPr>
+            <p:cNvSpPr/>
+            <p:nvPr/>
+          </p:nvSpPr>
+          <p:spPr>
+            <a:xfrm>
+              <a:off x="6017263" y="3661670"/>
+              <a:ext cx="1505632" cy="326746"/>
+            </a:xfrm>
+            <a:prstGeom prst="flowChartProcess">
+              <a:avLst/>
+            </a:prstGeom>
+          </p:spPr>
+          <p:style>
+            <a:lnRef idx="2">
+              <a:schemeClr val="accent1">
+                <a:shade val="15000"/>
+              </a:schemeClr>
+            </a:lnRef>
+            <a:fillRef idx="1">
+              <a:schemeClr val="accent1"/>
+            </a:fillRef>
+            <a:effectRef idx="0">
+              <a:schemeClr val="accent1"/>
+            </a:effectRef>
+            <a:fontRef idx="minor">
+              <a:schemeClr val="lt1"/>
+            </a:fontRef>
+          </p:style>
+          <p:txBody>
+            <a:bodyPr rtlCol="0" anchor="ctr"/>
+            <a:lstStyle/>
+            <a:p>
+              <a:pPr algn="ctr"/>
+              <a:r>
+                <a:rPr lang="en-US" altLang="zh-CN" dirty="0"/>
+                <a:t>TX4-MSG0</a:t>
+              </a:r>
+              <a:endParaRPr lang="zh-CN" altLang="en-US" dirty="0"/>
+            </a:p>
+          </p:txBody>
+        </p:sp>
+        <p:sp>
+          <p:nvSpPr>
+            <p:cNvPr id="22" name="文本框 21">
+              <a:extLst>
+                <a:ext uri="{FF2B5EF4-FFF2-40B4-BE49-F238E27FC236}">
+                  <a16:creationId xmlns:a16="http://schemas.microsoft.com/office/drawing/2014/main" id="{556E670A-2A49-911F-9E6F-A89B4509CB0A}"/>
+                </a:ext>
+              </a:extLst>
+            </p:cNvPr>
+            <p:cNvSpPr txBox="1"/>
+            <p:nvPr/>
+          </p:nvSpPr>
+          <p:spPr>
+            <a:xfrm>
+              <a:off x="9381850" y="353176"/>
+              <a:ext cx="1207698" cy="369332"/>
+            </a:xfrm>
+            <a:prstGeom prst="rect">
+              <a:avLst/>
+            </a:prstGeom>
+            <a:noFill/>
+          </p:spPr>
+          <p:txBody>
+            <a:bodyPr wrap="square" rtlCol="0">
+              <a:spAutoFit/>
+            </a:bodyPr>
+            <a:lstStyle/>
+            <a:p>
+              <a:r>
+                <a:rPr lang="en-US" altLang="zh-CN" b="1" dirty="0"/>
+                <a:t>CAN RX</a:t>
+              </a:r>
+            </a:p>
+          </p:txBody>
+        </p:sp>
+        <p:sp>
+          <p:nvSpPr>
+            <p:cNvPr id="25" name="流程图: 过程 24">
+              <a:extLst>
+                <a:ext uri="{FF2B5EF4-FFF2-40B4-BE49-F238E27FC236}">
+                  <a16:creationId xmlns:a16="http://schemas.microsoft.com/office/drawing/2014/main" id="{06F6D7FC-34A1-A141-8AEF-F4FF0F98CF06}"/>
+                </a:ext>
+              </a:extLst>
+            </p:cNvPr>
+            <p:cNvSpPr/>
+            <p:nvPr/>
+          </p:nvSpPr>
+          <p:spPr>
+            <a:xfrm>
+              <a:off x="9232883" y="770921"/>
+              <a:ext cx="1505632" cy="369332"/>
+            </a:xfrm>
+            <a:prstGeom prst="flowChartProcess">
+              <a:avLst/>
+            </a:prstGeom>
+          </p:spPr>
+          <p:style>
+            <a:lnRef idx="2">
+              <a:schemeClr val="accent1">
+                <a:shade val="15000"/>
+              </a:schemeClr>
+            </a:lnRef>
+            <a:fillRef idx="1">
+              <a:schemeClr val="accent1"/>
+            </a:fillRef>
+            <a:effectRef idx="0">
+              <a:schemeClr val="accent1"/>
+            </a:effectRef>
+            <a:fontRef idx="minor">
+              <a:schemeClr val="lt1"/>
+            </a:fontRef>
+          </p:style>
+          <p:txBody>
+            <a:bodyPr rtlCol="0" anchor="ctr"/>
+            <a:lstStyle/>
+            <a:p>
+              <a:pPr algn="ctr"/>
+              <a:r>
+                <a:rPr lang="en-US" altLang="zh-CN" dirty="0"/>
+                <a:t>RX1-MSG0</a:t>
+              </a:r>
+              <a:endParaRPr lang="zh-CN" altLang="en-US" dirty="0"/>
+            </a:p>
+          </p:txBody>
+        </p:sp>
+        <p:sp>
+          <p:nvSpPr>
+            <p:cNvPr id="26" name="流程图: 过程 25">
+              <a:extLst>
+                <a:ext uri="{FF2B5EF4-FFF2-40B4-BE49-F238E27FC236}">
+                  <a16:creationId xmlns:a16="http://schemas.microsoft.com/office/drawing/2014/main" id="{D7CD7E09-CFC8-E4C5-0DFB-1751F26EB582}"/>
+                </a:ext>
+              </a:extLst>
+            </p:cNvPr>
+            <p:cNvSpPr/>
+            <p:nvPr/>
+          </p:nvSpPr>
+          <p:spPr>
+            <a:xfrm>
+              <a:off x="9232883" y="1157118"/>
+              <a:ext cx="1505632" cy="369332"/>
+            </a:xfrm>
+            <a:prstGeom prst="flowChartProcess">
+              <a:avLst/>
+            </a:prstGeom>
+          </p:spPr>
+          <p:style>
+            <a:lnRef idx="2">
+              <a:schemeClr val="accent1">
+                <a:shade val="15000"/>
+              </a:schemeClr>
+            </a:lnRef>
+            <a:fillRef idx="1">
+              <a:schemeClr val="accent1"/>
+            </a:fillRef>
+            <a:effectRef idx="0">
+              <a:schemeClr val="accent1"/>
+            </a:effectRef>
+            <a:fontRef idx="minor">
+              <a:schemeClr val="lt1"/>
+            </a:fontRef>
+          </p:style>
+          <p:txBody>
+            <a:bodyPr rtlCol="0" anchor="ctr"/>
+            <a:lstStyle/>
+            <a:p>
+              <a:pPr algn="ctr"/>
+              <a:r>
+                <a:rPr lang="en-US" altLang="zh-CN" dirty="0"/>
+                <a:t>RX1-MSG1</a:t>
+              </a:r>
+              <a:endParaRPr lang="zh-CN" altLang="en-US" dirty="0"/>
+            </a:p>
+          </p:txBody>
+        </p:sp>
+        <p:sp>
+          <p:nvSpPr>
+            <p:cNvPr id="27" name="流程图: 过程 26">
+              <a:extLst>
+                <a:ext uri="{FF2B5EF4-FFF2-40B4-BE49-F238E27FC236}">
+                  <a16:creationId xmlns:a16="http://schemas.microsoft.com/office/drawing/2014/main" id="{BC603BCD-7202-99CE-F395-AD57A7F5FB3E}"/>
+                </a:ext>
+              </a:extLst>
+            </p:cNvPr>
+            <p:cNvSpPr/>
+            <p:nvPr/>
+          </p:nvSpPr>
+          <p:spPr>
+            <a:xfrm>
+              <a:off x="9232883" y="1543316"/>
+              <a:ext cx="1505632" cy="369332"/>
+            </a:xfrm>
+            <a:prstGeom prst="flowChartProcess">
+              <a:avLst/>
+            </a:prstGeom>
+          </p:spPr>
+          <p:style>
+            <a:lnRef idx="2">
+              <a:schemeClr val="accent1">
+                <a:shade val="15000"/>
+              </a:schemeClr>
+            </a:lnRef>
+            <a:fillRef idx="1">
+              <a:schemeClr val="accent1"/>
+            </a:fillRef>
+            <a:effectRef idx="0">
+              <a:schemeClr val="accent1"/>
+            </a:effectRef>
+            <a:fontRef idx="minor">
+              <a:schemeClr val="lt1"/>
+            </a:fontRef>
+          </p:style>
+          <p:txBody>
+            <a:bodyPr rtlCol="0" anchor="ctr"/>
+            <a:lstStyle/>
+            <a:p>
+              <a:pPr algn="ctr"/>
+              <a:r>
+                <a:rPr lang="en-US" altLang="zh-CN" dirty="0"/>
+                <a:t>RX1-MSG2</a:t>
+              </a:r>
+              <a:endParaRPr lang="zh-CN" altLang="en-US" dirty="0"/>
+            </a:p>
+          </p:txBody>
+        </p:sp>
+        <p:sp>
+          <p:nvSpPr>
+            <p:cNvPr id="28" name="流程图: 过程 27">
+              <a:extLst>
+                <a:ext uri="{FF2B5EF4-FFF2-40B4-BE49-F238E27FC236}">
+                  <a16:creationId xmlns:a16="http://schemas.microsoft.com/office/drawing/2014/main" id="{38A59A7D-0851-388E-44D4-E7B19B55B72E}"/>
+                </a:ext>
+              </a:extLst>
+            </p:cNvPr>
+            <p:cNvSpPr/>
+            <p:nvPr/>
+          </p:nvSpPr>
+          <p:spPr>
+            <a:xfrm>
+              <a:off x="9232883" y="1929514"/>
+              <a:ext cx="1505632" cy="369332"/>
+            </a:xfrm>
+            <a:prstGeom prst="flowChartProcess">
+              <a:avLst/>
+            </a:prstGeom>
+          </p:spPr>
+          <p:style>
+            <a:lnRef idx="2">
+              <a:schemeClr val="accent1">
+                <a:shade val="15000"/>
+              </a:schemeClr>
+            </a:lnRef>
+            <a:fillRef idx="1">
+              <a:schemeClr val="accent1"/>
+            </a:fillRef>
+            <a:effectRef idx="0">
+              <a:schemeClr val="accent1"/>
+            </a:effectRef>
+            <a:fontRef idx="minor">
+              <a:schemeClr val="lt1"/>
+            </a:fontRef>
+          </p:style>
+          <p:txBody>
+            <a:bodyPr rtlCol="0" anchor="ctr"/>
+            <a:lstStyle/>
+            <a:p>
+              <a:pPr algn="ctr"/>
+              <a:r>
+                <a:rPr lang="en-US" altLang="zh-CN" dirty="0"/>
+                <a:t>RX1-MSG3</a:t>
+              </a:r>
+              <a:endParaRPr lang="zh-CN" altLang="en-US" dirty="0"/>
+            </a:p>
+          </p:txBody>
+        </p:sp>
+        <p:sp>
+          <p:nvSpPr>
+            <p:cNvPr id="29" name="流程图: 过程 28">
+              <a:extLst>
+                <a:ext uri="{FF2B5EF4-FFF2-40B4-BE49-F238E27FC236}">
+                  <a16:creationId xmlns:a16="http://schemas.microsoft.com/office/drawing/2014/main" id="{11A24E88-332C-0520-0F5F-629D841EB9D4}"/>
+                </a:ext>
+              </a:extLst>
+            </p:cNvPr>
+            <p:cNvSpPr/>
+            <p:nvPr/>
+          </p:nvSpPr>
+          <p:spPr>
+            <a:xfrm>
+              <a:off x="9232883" y="2875627"/>
+              <a:ext cx="1505632" cy="369332"/>
+            </a:xfrm>
+            <a:prstGeom prst="flowChartProcess">
+              <a:avLst/>
+            </a:prstGeom>
+          </p:spPr>
+          <p:style>
+            <a:lnRef idx="2">
+              <a:schemeClr val="accent1">
+                <a:shade val="15000"/>
+              </a:schemeClr>
+            </a:lnRef>
+            <a:fillRef idx="1">
+              <a:schemeClr val="accent1"/>
+            </a:fillRef>
+            <a:effectRef idx="0">
+              <a:schemeClr val="accent1"/>
+            </a:effectRef>
+            <a:fontRef idx="minor">
+              <a:schemeClr val="lt1"/>
+            </a:fontRef>
+          </p:style>
+          <p:txBody>
+            <a:bodyPr rtlCol="0" anchor="ctr"/>
+            <a:lstStyle/>
+            <a:p>
+              <a:pPr algn="ctr"/>
+              <a:r>
+                <a:rPr lang="en-US" altLang="zh-CN" dirty="0"/>
+                <a:t>RX4-MSG0</a:t>
+              </a:r>
+              <a:endParaRPr lang="zh-CN" altLang="en-US" dirty="0"/>
+            </a:p>
+          </p:txBody>
+        </p:sp>
+        <p:sp>
+          <p:nvSpPr>
+            <p:cNvPr id="30" name="流程图: 过程 29">
+              <a:extLst>
+                <a:ext uri="{FF2B5EF4-FFF2-40B4-BE49-F238E27FC236}">
+                  <a16:creationId xmlns:a16="http://schemas.microsoft.com/office/drawing/2014/main" id="{879B5D24-B17C-7C56-65D8-8904C9E5D869}"/>
+                </a:ext>
+              </a:extLst>
+            </p:cNvPr>
+            <p:cNvSpPr/>
+            <p:nvPr/>
+          </p:nvSpPr>
+          <p:spPr>
+            <a:xfrm>
+              <a:off x="9232883" y="3261824"/>
+              <a:ext cx="1505632" cy="369332"/>
+            </a:xfrm>
+            <a:prstGeom prst="flowChartProcess">
+              <a:avLst/>
+            </a:prstGeom>
+          </p:spPr>
+          <p:style>
+            <a:lnRef idx="2">
+              <a:schemeClr val="accent1">
+                <a:shade val="15000"/>
+              </a:schemeClr>
+            </a:lnRef>
+            <a:fillRef idx="1">
+              <a:schemeClr val="accent1"/>
+            </a:fillRef>
+            <a:effectRef idx="0">
+              <a:schemeClr val="accent1"/>
+            </a:effectRef>
+            <a:fontRef idx="minor">
+              <a:schemeClr val="lt1"/>
+            </a:fontRef>
+          </p:style>
+          <p:txBody>
+            <a:bodyPr rtlCol="0" anchor="ctr"/>
+            <a:lstStyle/>
+            <a:p>
+              <a:pPr algn="ctr"/>
+              <a:r>
+                <a:rPr lang="en-US" altLang="zh-CN" dirty="0"/>
+                <a:t>RX4-MSG1</a:t>
+              </a:r>
+              <a:endParaRPr lang="zh-CN" altLang="en-US" dirty="0"/>
+            </a:p>
+          </p:txBody>
+        </p:sp>
+        <p:sp>
+          <p:nvSpPr>
+            <p:cNvPr id="31" name="流程图: 过程 30">
+              <a:extLst>
+                <a:ext uri="{FF2B5EF4-FFF2-40B4-BE49-F238E27FC236}">
+                  <a16:creationId xmlns:a16="http://schemas.microsoft.com/office/drawing/2014/main" id="{6695EA77-D3A5-EB00-59B6-787C8960DA2E}"/>
+                </a:ext>
+              </a:extLst>
+            </p:cNvPr>
+            <p:cNvSpPr/>
+            <p:nvPr/>
+          </p:nvSpPr>
+          <p:spPr>
+            <a:xfrm>
+              <a:off x="9232883" y="3648022"/>
+              <a:ext cx="1505632" cy="369332"/>
+            </a:xfrm>
+            <a:prstGeom prst="flowChartProcess">
+              <a:avLst/>
+            </a:prstGeom>
+          </p:spPr>
+          <p:style>
+            <a:lnRef idx="2">
+              <a:schemeClr val="accent1">
+                <a:shade val="15000"/>
+              </a:schemeClr>
+            </a:lnRef>
+            <a:fillRef idx="1">
+              <a:schemeClr val="accent1"/>
+            </a:fillRef>
+            <a:effectRef idx="0">
+              <a:schemeClr val="accent1"/>
+            </a:effectRef>
+            <a:fontRef idx="minor">
+              <a:schemeClr val="lt1"/>
+            </a:fontRef>
+          </p:style>
+          <p:txBody>
+            <a:bodyPr rtlCol="0" anchor="ctr"/>
+            <a:lstStyle/>
+            <a:p>
+              <a:pPr algn="ctr"/>
+              <a:r>
+                <a:rPr lang="en-US" altLang="zh-CN" dirty="0"/>
+                <a:t>RX4-MSG2</a:t>
+              </a:r>
+              <a:endParaRPr lang="zh-CN" altLang="en-US" dirty="0"/>
+            </a:p>
+          </p:txBody>
+        </p:sp>
+        <p:sp>
+          <p:nvSpPr>
+            <p:cNvPr id="32" name="流程图: 过程 31">
+              <a:extLst>
+                <a:ext uri="{FF2B5EF4-FFF2-40B4-BE49-F238E27FC236}">
+                  <a16:creationId xmlns:a16="http://schemas.microsoft.com/office/drawing/2014/main" id="{79146F44-E04B-3287-A3E1-652E2B556478}"/>
+                </a:ext>
+              </a:extLst>
+            </p:cNvPr>
+            <p:cNvSpPr/>
+            <p:nvPr/>
+          </p:nvSpPr>
+          <p:spPr>
+            <a:xfrm>
+              <a:off x="9232883" y="4034220"/>
+              <a:ext cx="1505632" cy="369332"/>
+            </a:xfrm>
+            <a:prstGeom prst="flowChartProcess">
+              <a:avLst/>
+            </a:prstGeom>
+          </p:spPr>
+          <p:style>
+            <a:lnRef idx="2">
+              <a:schemeClr val="accent1">
+                <a:shade val="15000"/>
+              </a:schemeClr>
+            </a:lnRef>
+            <a:fillRef idx="1">
+              <a:schemeClr val="accent1"/>
+            </a:fillRef>
+            <a:effectRef idx="0">
+              <a:schemeClr val="accent1"/>
+            </a:effectRef>
+            <a:fontRef idx="minor">
+              <a:schemeClr val="lt1"/>
+            </a:fontRef>
+          </p:style>
+          <p:txBody>
+            <a:bodyPr rtlCol="0" anchor="ctr"/>
+            <a:lstStyle/>
+            <a:p>
+              <a:pPr algn="ctr"/>
+              <a:r>
+                <a:rPr lang="en-US" altLang="zh-CN" dirty="0"/>
+                <a:t>RX4-MSG3</a:t>
+              </a:r>
+              <a:endParaRPr lang="zh-CN" altLang="en-US" dirty="0"/>
+            </a:p>
+          </p:txBody>
+        </p:sp>
+        <p:sp>
+          <p:nvSpPr>
+            <p:cNvPr id="33" name="文本框 32">
+              <a:extLst>
+                <a:ext uri="{FF2B5EF4-FFF2-40B4-BE49-F238E27FC236}">
+                  <a16:creationId xmlns:a16="http://schemas.microsoft.com/office/drawing/2014/main" id="{B37B293A-6735-3C80-8C32-753BE057C769}"/>
+                </a:ext>
+              </a:extLst>
+            </p:cNvPr>
+            <p:cNvSpPr txBox="1"/>
+            <p:nvPr/>
+          </p:nvSpPr>
+          <p:spPr>
+            <a:xfrm>
+              <a:off x="9812414" y="2356404"/>
+              <a:ext cx="434734" cy="461665"/>
+            </a:xfrm>
+            <a:prstGeom prst="rect">
+              <a:avLst/>
+            </a:prstGeom>
+            <a:noFill/>
+          </p:spPr>
+          <p:txBody>
+            <a:bodyPr wrap="none" rtlCol="0">
+              <a:spAutoFit/>
+            </a:bodyPr>
+            <a:lstStyle/>
+            <a:p>
+              <a:r>
+                <a:rPr lang="en-US" altLang="zh-CN" sz="2400" b="1" dirty="0"/>
+                <a:t>…</a:t>
+              </a:r>
+              <a:endParaRPr lang="zh-CN" altLang="en-US" b="1" dirty="0"/>
+            </a:p>
+          </p:txBody>
+        </p:sp>
+        <p:cxnSp>
+          <p:nvCxnSpPr>
+            <p:cNvPr id="35" name="直接箭头连接符 34">
+              <a:extLst>
+                <a:ext uri="{FF2B5EF4-FFF2-40B4-BE49-F238E27FC236}">
+                  <a16:creationId xmlns:a16="http://schemas.microsoft.com/office/drawing/2014/main" id="{48C9E777-4108-F52A-5EB1-FBBF31AFB778}"/>
+                </a:ext>
+              </a:extLst>
+            </p:cNvPr>
+            <p:cNvCxnSpPr>
+              <a:stCxn id="13" idx="3"/>
+              <a:endCxn id="25" idx="1"/>
+            </p:cNvCxnSpPr>
+            <p:nvPr/>
+          </p:nvCxnSpPr>
+          <p:spPr>
+            <a:xfrm flipV="1">
+              <a:off x="7522895" y="955587"/>
+              <a:ext cx="1709988" cy="16865"/>
+            </a:xfrm>
+            <a:prstGeom prst="straightConnector1">
+              <a:avLst/>
+            </a:prstGeom>
+            <a:ln>
+              <a:tailEnd type="triangle"/>
+            </a:ln>
+          </p:spPr>
+          <p:style>
+            <a:lnRef idx="1">
+              <a:schemeClr val="accent1"/>
+            </a:lnRef>
+            <a:fillRef idx="0">
+              <a:schemeClr val="accent1"/>
+            </a:fillRef>
+            <a:effectRef idx="0">
+              <a:schemeClr val="accent1"/>
+            </a:effectRef>
+            <a:fontRef idx="minor">
+              <a:schemeClr val="tx1"/>
+            </a:fontRef>
+          </p:style>
+        </p:cxnSp>
+        <p:cxnSp>
+          <p:nvCxnSpPr>
+            <p:cNvPr id="37" name="直接箭头连接符 36">
+              <a:extLst>
+                <a:ext uri="{FF2B5EF4-FFF2-40B4-BE49-F238E27FC236}">
+                  <a16:creationId xmlns:a16="http://schemas.microsoft.com/office/drawing/2014/main" id="{1CE956B0-DDD2-62A0-368A-CFFDE4250F62}"/>
+                </a:ext>
+              </a:extLst>
+            </p:cNvPr>
+            <p:cNvCxnSpPr>
+              <a:stCxn id="15" idx="3"/>
+              <a:endCxn id="26" idx="1"/>
+            </p:cNvCxnSpPr>
+            <p:nvPr/>
+          </p:nvCxnSpPr>
+          <p:spPr>
+            <a:xfrm flipV="1">
+              <a:off x="7522895" y="1341784"/>
+              <a:ext cx="1709988" cy="602825"/>
+            </a:xfrm>
+            <a:prstGeom prst="straightConnector1">
+              <a:avLst/>
+            </a:prstGeom>
+            <a:ln>
+              <a:tailEnd type="triangle"/>
+            </a:ln>
+          </p:spPr>
+          <p:style>
+            <a:lnRef idx="1">
+              <a:schemeClr val="accent1"/>
+            </a:lnRef>
+            <a:fillRef idx="0">
+              <a:schemeClr val="accent1"/>
+            </a:fillRef>
+            <a:effectRef idx="0">
+              <a:schemeClr val="accent1"/>
+            </a:effectRef>
+            <a:fontRef idx="minor">
+              <a:schemeClr val="tx1"/>
+            </a:fontRef>
+          </p:style>
+        </p:cxnSp>
+        <p:cxnSp>
+          <p:nvCxnSpPr>
+            <p:cNvPr id="39" name="直接箭头连接符 38">
+              <a:extLst>
+                <a:ext uri="{FF2B5EF4-FFF2-40B4-BE49-F238E27FC236}">
+                  <a16:creationId xmlns:a16="http://schemas.microsoft.com/office/drawing/2014/main" id="{06F7416D-9F14-723B-4835-5B018D4A5040}"/>
+                </a:ext>
+              </a:extLst>
+            </p:cNvPr>
+            <p:cNvCxnSpPr>
+              <a:stCxn id="17" idx="3"/>
+              <a:endCxn id="27" idx="1"/>
+            </p:cNvCxnSpPr>
+            <p:nvPr/>
+          </p:nvCxnSpPr>
+          <p:spPr>
+            <a:xfrm flipV="1">
+              <a:off x="7522895" y="1727982"/>
+              <a:ext cx="1709988" cy="1167491"/>
+            </a:xfrm>
+            <a:prstGeom prst="straightConnector1">
+              <a:avLst/>
+            </a:prstGeom>
+            <a:ln>
+              <a:tailEnd type="triangle"/>
+            </a:ln>
+          </p:spPr>
+          <p:style>
+            <a:lnRef idx="1">
+              <a:schemeClr val="accent1"/>
+            </a:lnRef>
+            <a:fillRef idx="0">
+              <a:schemeClr val="accent1"/>
+            </a:fillRef>
+            <a:effectRef idx="0">
+              <a:schemeClr val="accent1"/>
+            </a:effectRef>
+            <a:fontRef idx="minor">
+              <a:schemeClr val="tx1"/>
+            </a:fontRef>
+          </p:style>
+        </p:cxnSp>
+        <p:cxnSp>
+          <p:nvCxnSpPr>
+            <p:cNvPr id="41" name="直接箭头连接符 40">
+              <a:extLst>
+                <a:ext uri="{FF2B5EF4-FFF2-40B4-BE49-F238E27FC236}">
+                  <a16:creationId xmlns:a16="http://schemas.microsoft.com/office/drawing/2014/main" id="{F76BEED9-D6A7-76D9-09C1-1D8AF32466A7}"/>
+                </a:ext>
+              </a:extLst>
+            </p:cNvPr>
+            <p:cNvCxnSpPr>
+              <a:stCxn id="19" idx="3"/>
+              <a:endCxn id="28" idx="1"/>
+            </p:cNvCxnSpPr>
+            <p:nvPr/>
+          </p:nvCxnSpPr>
+          <p:spPr>
+            <a:xfrm flipV="1">
+              <a:off x="7522895" y="2114180"/>
+              <a:ext cx="1709988" cy="1710863"/>
+            </a:xfrm>
+            <a:prstGeom prst="straightConnector1">
+              <a:avLst/>
+            </a:prstGeom>
+            <a:ln>
+              <a:tailEnd type="triangle"/>
+            </a:ln>
+          </p:spPr>
+          <p:style>
+            <a:lnRef idx="1">
+              <a:schemeClr val="accent1"/>
+            </a:lnRef>
+            <a:fillRef idx="0">
+              <a:schemeClr val="accent1"/>
+            </a:fillRef>
+            <a:effectRef idx="0">
+              <a:schemeClr val="accent1"/>
+            </a:effectRef>
+            <a:fontRef idx="minor">
+              <a:schemeClr val="tx1"/>
+            </a:fontRef>
+          </p:style>
+        </p:cxnSp>
+        <p:cxnSp>
+          <p:nvCxnSpPr>
+            <p:cNvPr id="43" name="直接箭头连接符 42">
+              <a:extLst>
+                <a:ext uri="{FF2B5EF4-FFF2-40B4-BE49-F238E27FC236}">
+                  <a16:creationId xmlns:a16="http://schemas.microsoft.com/office/drawing/2014/main" id="{E61F206E-698D-AB45-35F6-07FF7E7E34A5}"/>
+                </a:ext>
+              </a:extLst>
+            </p:cNvPr>
+            <p:cNvCxnSpPr>
+              <a:stCxn id="13" idx="3"/>
+              <a:endCxn id="29" idx="1"/>
+            </p:cNvCxnSpPr>
+            <p:nvPr/>
+          </p:nvCxnSpPr>
+          <p:spPr>
+            <a:xfrm>
+              <a:off x="7522895" y="972452"/>
+              <a:ext cx="1709988" cy="2087841"/>
+            </a:xfrm>
+            <a:prstGeom prst="straightConnector1">
+              <a:avLst/>
+            </a:prstGeom>
+            <a:ln>
+              <a:tailEnd type="triangle"/>
+            </a:ln>
+          </p:spPr>
+          <p:style>
+            <a:lnRef idx="1">
+              <a:schemeClr val="accent1"/>
+            </a:lnRef>
+            <a:fillRef idx="0">
+              <a:schemeClr val="accent1"/>
+            </a:fillRef>
+            <a:effectRef idx="0">
+              <a:schemeClr val="accent1"/>
+            </a:effectRef>
+            <a:fontRef idx="minor">
+              <a:schemeClr val="tx1"/>
+            </a:fontRef>
+          </p:style>
+        </p:cxnSp>
+        <p:cxnSp>
+          <p:nvCxnSpPr>
+            <p:cNvPr id="45" name="直接箭头连接符 44">
+              <a:extLst>
+                <a:ext uri="{FF2B5EF4-FFF2-40B4-BE49-F238E27FC236}">
+                  <a16:creationId xmlns:a16="http://schemas.microsoft.com/office/drawing/2014/main" id="{E76D12F4-4291-C4A1-128B-62208D469449}"/>
+                </a:ext>
+              </a:extLst>
+            </p:cNvPr>
+            <p:cNvCxnSpPr>
+              <a:stCxn id="15" idx="3"/>
+              <a:endCxn id="30" idx="1"/>
+            </p:cNvCxnSpPr>
+            <p:nvPr/>
+          </p:nvCxnSpPr>
+          <p:spPr>
+            <a:xfrm>
+              <a:off x="7522895" y="1944609"/>
+              <a:ext cx="1709988" cy="1501881"/>
+            </a:xfrm>
+            <a:prstGeom prst="straightConnector1">
+              <a:avLst/>
+            </a:prstGeom>
+            <a:ln>
+              <a:tailEnd type="triangle"/>
+            </a:ln>
+          </p:spPr>
+          <p:style>
+            <a:lnRef idx="1">
+              <a:schemeClr val="accent1"/>
+            </a:lnRef>
+            <a:fillRef idx="0">
+              <a:schemeClr val="accent1"/>
+            </a:fillRef>
+            <a:effectRef idx="0">
+              <a:schemeClr val="accent1"/>
+            </a:effectRef>
+            <a:fontRef idx="minor">
+              <a:schemeClr val="tx1"/>
+            </a:fontRef>
+          </p:style>
+        </p:cxnSp>
+        <p:cxnSp>
+          <p:nvCxnSpPr>
+            <p:cNvPr id="47" name="直接箭头连接符 46">
+              <a:extLst>
+                <a:ext uri="{FF2B5EF4-FFF2-40B4-BE49-F238E27FC236}">
+                  <a16:creationId xmlns:a16="http://schemas.microsoft.com/office/drawing/2014/main" id="{79018392-EF31-D87F-1882-E6799D16F5BE}"/>
+                </a:ext>
+              </a:extLst>
+            </p:cNvPr>
+            <p:cNvCxnSpPr>
+              <a:stCxn id="17" idx="3"/>
+              <a:endCxn id="31" idx="1"/>
+            </p:cNvCxnSpPr>
+            <p:nvPr/>
+          </p:nvCxnSpPr>
+          <p:spPr>
+            <a:xfrm>
+              <a:off x="7522895" y="2895473"/>
+              <a:ext cx="1709988" cy="937215"/>
+            </a:xfrm>
+            <a:prstGeom prst="straightConnector1">
+              <a:avLst/>
+            </a:prstGeom>
+            <a:ln>
+              <a:tailEnd type="triangle"/>
+            </a:ln>
+          </p:spPr>
+          <p:style>
+            <a:lnRef idx="1">
+              <a:schemeClr val="accent1"/>
+            </a:lnRef>
+            <a:fillRef idx="0">
+              <a:schemeClr val="accent1"/>
+            </a:fillRef>
+            <a:effectRef idx="0">
+              <a:schemeClr val="accent1"/>
+            </a:effectRef>
+            <a:fontRef idx="minor">
+              <a:schemeClr val="tx1"/>
+            </a:fontRef>
+          </p:style>
+        </p:cxnSp>
+        <p:cxnSp>
+          <p:nvCxnSpPr>
+            <p:cNvPr id="49" name="直接箭头连接符 48">
+              <a:extLst>
+                <a:ext uri="{FF2B5EF4-FFF2-40B4-BE49-F238E27FC236}">
+                  <a16:creationId xmlns:a16="http://schemas.microsoft.com/office/drawing/2014/main" id="{C109FC4E-8E6F-D90C-4099-0AC47290C8AE}"/>
+                </a:ext>
+              </a:extLst>
+            </p:cNvPr>
+            <p:cNvCxnSpPr>
+              <a:stCxn id="19" idx="3"/>
+              <a:endCxn id="32" idx="1"/>
+            </p:cNvCxnSpPr>
+            <p:nvPr/>
+          </p:nvCxnSpPr>
+          <p:spPr>
+            <a:xfrm>
+              <a:off x="7522895" y="3825043"/>
+              <a:ext cx="1709988" cy="393843"/>
+            </a:xfrm>
+            <a:prstGeom prst="straightConnector1">
+              <a:avLst/>
+            </a:prstGeom>
+            <a:ln>
+              <a:tailEnd type="triangle"/>
+            </a:ln>
+          </p:spPr>
+          <p:style>
+            <a:lnRef idx="1">
+              <a:schemeClr val="accent1"/>
+            </a:lnRef>
+            <a:fillRef idx="0">
+              <a:schemeClr val="accent1"/>
+            </a:fillRef>
+            <a:effectRef idx="0">
+              <a:schemeClr val="accent1"/>
+            </a:effectRef>
+            <a:fontRef idx="minor">
+              <a:schemeClr val="tx1"/>
+            </a:fontRef>
+          </p:style>
+        </p:cxnSp>
+      </p:grpSp>
     </p:spTree>
     <p:extLst>
       <p:ext uri="{BB962C8B-B14F-4D97-AF65-F5344CB8AC3E}">

</xml_diff>